<commit_message>
A2 poster şablonu ve yazı boyutu kuralını güncelle
Şablon dosyaları gerçek A2 (420x594 mm) boyutuna getirildi; 28 pt zorunluluğu yerine okunabilir yazı boyutu (gövde için en az 16 pt önerisi) yazıldı.

Co-Authored-By: Claude Sonnet 5.5 <noreply@anthropic.com>
</commit_message>
<xml_diff>
--- a/public/templates/hidrojen-zirvesi-a2-poster-sablonu.pptx
+++ b/public/templates/hidrojen-zirvesi-a2-poster-sablonu.pptx
@@ -10,7 +10,7 @@
   <p:notesMasterIdLst>
     <p:notesMasterId r:id="rId3"/>
   </p:notesMasterIdLst>
-  <p:sldSz cx="21384158" cy="30275784"/>
+  <p:sldSz cx="15120000" cy="21384000"/>
   <p:notesSz cx="30275784" cy="21384158"/>
   <p:defaultTextStyle>
     <a:lvl1pPr marL="0" algn="l" defTabSz="914400" rtl="0" eaLnBrk="1" latinLnBrk="0" hangingPunct="1">
@@ -605,7 +605,7 @@
           <a:spcPct val="0"/>
         </a:spcBef>
         <a:buNone/>
-        <a:defRPr sz="4400" kern="1200">
+        <a:defRPr sz="3111" kern="1200">
           <a:solidFill>
             <a:schemeClr val="tx1"/>
           </a:solidFill>
@@ -616,13 +616,13 @@
       </a:lvl1pPr>
     </p:titleStyle>
     <p:bodyStyle>
-      <a:lvl1pPr marL="342900" indent="-342900" algn="l" defTabSz="914400" rtl="0" eaLnBrk="1" latinLnBrk="0" hangingPunct="1">
+      <a:lvl1pPr marL="242455" indent="-242455" algn="l" defTabSz="914400" rtl="0" eaLnBrk="1" latinLnBrk="0" hangingPunct="1">
         <a:spcBef>
           <a:spcPct val="20000"/>
         </a:spcBef>
         <a:buFont typeface="Arial" pitchFamily="34" charset="0"/>
         <a:buChar char="•"/>
-        <a:defRPr sz="3200" kern="1200">
+        <a:defRPr sz="2263" kern="1200">
           <a:solidFill>
             <a:schemeClr val="tx1"/>
           </a:solidFill>
@@ -631,13 +631,13 @@
           <a:cs typeface="+mn-cs"/>
         </a:defRPr>
       </a:lvl1pPr>
-      <a:lvl2pPr marL="742950" indent="-285750" algn="l" defTabSz="914400" rtl="0" eaLnBrk="1" latinLnBrk="0" hangingPunct="1">
+      <a:lvl2pPr marL="525318" indent="-202045" algn="l" defTabSz="914400" rtl="0" eaLnBrk="1" latinLnBrk="0" hangingPunct="1">
         <a:spcBef>
           <a:spcPct val="20000"/>
         </a:spcBef>
         <a:buFont typeface="Arial" pitchFamily="34" charset="0"/>
         <a:buChar char="–"/>
-        <a:defRPr sz="2800" kern="1200">
+        <a:defRPr sz="1980" kern="1200">
           <a:solidFill>
             <a:schemeClr val="tx1"/>
           </a:solidFill>
@@ -646,13 +646,13 @@
           <a:cs typeface="+mn-cs"/>
         </a:defRPr>
       </a:lvl2pPr>
-      <a:lvl3pPr marL="1143000" indent="-228600" algn="l" defTabSz="914400" rtl="0" eaLnBrk="1" latinLnBrk="0" hangingPunct="1">
+      <a:lvl3pPr marL="808182" indent="-161636" algn="l" defTabSz="914400" rtl="0" eaLnBrk="1" latinLnBrk="0" hangingPunct="1">
         <a:spcBef>
           <a:spcPct val="20000"/>
         </a:spcBef>
         <a:buFont typeface="Arial" pitchFamily="34" charset="0"/>
         <a:buChar char="•"/>
-        <a:defRPr sz="2400" kern="1200">
+        <a:defRPr sz="1697" kern="1200">
           <a:solidFill>
             <a:schemeClr val="tx1"/>
           </a:solidFill>
@@ -661,13 +661,13 @@
           <a:cs typeface="+mn-cs"/>
         </a:defRPr>
       </a:lvl3pPr>
-      <a:lvl4pPr marL="1600200" indent="-228600" algn="l" defTabSz="914400" rtl="0" eaLnBrk="1" latinLnBrk="0" hangingPunct="1">
+      <a:lvl4pPr marL="1131455" indent="-161636" algn="l" defTabSz="914400" rtl="0" eaLnBrk="1" latinLnBrk="0" hangingPunct="1">
         <a:spcBef>
           <a:spcPct val="20000"/>
         </a:spcBef>
         <a:buFont typeface="Arial" pitchFamily="34" charset="0"/>
         <a:buChar char="–"/>
-        <a:defRPr sz="2000" kern="1200">
+        <a:defRPr sz="1414" kern="1200">
           <a:solidFill>
             <a:schemeClr val="tx1"/>
           </a:solidFill>
@@ -676,13 +676,13 @@
           <a:cs typeface="+mn-cs"/>
         </a:defRPr>
       </a:lvl4pPr>
-      <a:lvl5pPr marL="2057400" indent="-228600" algn="l" defTabSz="914400" rtl="0" eaLnBrk="1" latinLnBrk="0" hangingPunct="1">
+      <a:lvl5pPr marL="1454727" indent="-161636" algn="l" defTabSz="914400" rtl="0" eaLnBrk="1" latinLnBrk="0" hangingPunct="1">
         <a:spcBef>
           <a:spcPct val="20000"/>
         </a:spcBef>
         <a:buFont typeface="Arial" pitchFamily="34" charset="0"/>
         <a:buChar char="»"/>
-        <a:defRPr sz="2000" kern="1200">
+        <a:defRPr sz="1414" kern="1200">
           <a:solidFill>
             <a:schemeClr val="tx1"/>
           </a:solidFill>
@@ -691,13 +691,13 @@
           <a:cs typeface="+mn-cs"/>
         </a:defRPr>
       </a:lvl5pPr>
-      <a:lvl6pPr marL="2514600" indent="-228600" algn="l" defTabSz="914400" rtl="0" eaLnBrk="1" latinLnBrk="0" hangingPunct="1">
+      <a:lvl6pPr marL="1778000" indent="-161636" algn="l" defTabSz="914400" rtl="0" eaLnBrk="1" latinLnBrk="0" hangingPunct="1">
         <a:spcBef>
           <a:spcPct val="20000"/>
         </a:spcBef>
         <a:buFont typeface="Arial" pitchFamily="34" charset="0"/>
         <a:buChar char="•"/>
-        <a:defRPr sz="2000" kern="1200">
+        <a:defRPr sz="1414" kern="1200">
           <a:solidFill>
             <a:schemeClr val="tx1"/>
           </a:solidFill>
@@ -706,13 +706,13 @@
           <a:cs typeface="+mn-cs"/>
         </a:defRPr>
       </a:lvl6pPr>
-      <a:lvl7pPr marL="2971800" indent="-228600" algn="l" defTabSz="914400" rtl="0" eaLnBrk="1" latinLnBrk="0" hangingPunct="1">
+      <a:lvl7pPr marL="2101273" indent="-161636" algn="l" defTabSz="914400" rtl="0" eaLnBrk="1" latinLnBrk="0" hangingPunct="1">
         <a:spcBef>
           <a:spcPct val="20000"/>
         </a:spcBef>
         <a:buFont typeface="Arial" pitchFamily="34" charset="0"/>
         <a:buChar char="•"/>
-        <a:defRPr sz="2000" kern="1200">
+        <a:defRPr sz="1414" kern="1200">
           <a:solidFill>
             <a:schemeClr val="tx1"/>
           </a:solidFill>
@@ -721,13 +721,13 @@
           <a:cs typeface="+mn-cs"/>
         </a:defRPr>
       </a:lvl7pPr>
-      <a:lvl8pPr marL="3429000" indent="-228600" algn="l" defTabSz="914400" rtl="0" eaLnBrk="1" latinLnBrk="0" hangingPunct="1">
+      <a:lvl8pPr marL="2424545" indent="-161636" algn="l" defTabSz="914400" rtl="0" eaLnBrk="1" latinLnBrk="0" hangingPunct="1">
         <a:spcBef>
           <a:spcPct val="20000"/>
         </a:spcBef>
         <a:buFont typeface="Arial" pitchFamily="34" charset="0"/>
         <a:buChar char="•"/>
-        <a:defRPr sz="2000" kern="1200">
+        <a:defRPr sz="1414" kern="1200">
           <a:solidFill>
             <a:schemeClr val="tx1"/>
           </a:solidFill>
@@ -736,13 +736,13 @@
           <a:cs typeface="+mn-cs"/>
         </a:defRPr>
       </a:lvl8pPr>
-      <a:lvl9pPr marL="3886200" indent="-228600" algn="l" defTabSz="914400" rtl="0" eaLnBrk="1" latinLnBrk="0" hangingPunct="1">
+      <a:lvl9pPr marL="2747818" indent="-161636" algn="l" defTabSz="914400" rtl="0" eaLnBrk="1" latinLnBrk="0" hangingPunct="1">
         <a:spcBef>
           <a:spcPct val="20000"/>
         </a:spcBef>
         <a:buFont typeface="Arial" pitchFamily="34" charset="0"/>
         <a:buChar char="•"/>
-        <a:defRPr sz="2000" kern="1200">
+        <a:defRPr sz="1414" kern="1200">
           <a:solidFill>
             <a:schemeClr val="tx1"/>
           </a:solidFill>
@@ -757,7 +757,7 @@
         <a:defRPr lang="en-US"/>
       </a:defPPr>
       <a:lvl1pPr marL="0" algn="l" defTabSz="914400" rtl="0" eaLnBrk="1" latinLnBrk="0" hangingPunct="1">
-        <a:defRPr sz="1800" kern="1200">
+        <a:defRPr sz="1273" kern="1200">
           <a:solidFill>
             <a:schemeClr val="tx1"/>
           </a:solidFill>
@@ -766,8 +766,8 @@
           <a:cs typeface="+mn-cs"/>
         </a:defRPr>
       </a:lvl1pPr>
-      <a:lvl2pPr marL="457200" algn="l" defTabSz="914400" rtl="0" eaLnBrk="1" latinLnBrk="0" hangingPunct="1">
-        <a:defRPr sz="1800" kern="1200">
+      <a:lvl2pPr marL="323273" algn="l" defTabSz="914400" rtl="0" eaLnBrk="1" latinLnBrk="0" hangingPunct="1">
+        <a:defRPr sz="1273" kern="1200">
           <a:solidFill>
             <a:schemeClr val="tx1"/>
           </a:solidFill>
@@ -776,8 +776,8 @@
           <a:cs typeface="+mn-cs"/>
         </a:defRPr>
       </a:lvl2pPr>
-      <a:lvl3pPr marL="914400" algn="l" defTabSz="914400" rtl="0" eaLnBrk="1" latinLnBrk="0" hangingPunct="1">
-        <a:defRPr sz="1800" kern="1200">
+      <a:lvl3pPr marL="646545" algn="l" defTabSz="914400" rtl="0" eaLnBrk="1" latinLnBrk="0" hangingPunct="1">
+        <a:defRPr sz="1273" kern="1200">
           <a:solidFill>
             <a:schemeClr val="tx1"/>
           </a:solidFill>
@@ -786,8 +786,8 @@
           <a:cs typeface="+mn-cs"/>
         </a:defRPr>
       </a:lvl3pPr>
-      <a:lvl4pPr marL="1371600" algn="l" defTabSz="914400" rtl="0" eaLnBrk="1" latinLnBrk="0" hangingPunct="1">
-        <a:defRPr sz="1800" kern="1200">
+      <a:lvl4pPr marL="969818" algn="l" defTabSz="914400" rtl="0" eaLnBrk="1" latinLnBrk="0" hangingPunct="1">
+        <a:defRPr sz="1273" kern="1200">
           <a:solidFill>
             <a:schemeClr val="tx1"/>
           </a:solidFill>
@@ -796,8 +796,8 @@
           <a:cs typeface="+mn-cs"/>
         </a:defRPr>
       </a:lvl4pPr>
-      <a:lvl5pPr marL="1828800" algn="l" defTabSz="914400" rtl="0" eaLnBrk="1" latinLnBrk="0" hangingPunct="1">
-        <a:defRPr sz="1800" kern="1200">
+      <a:lvl5pPr marL="1293091" algn="l" defTabSz="914400" rtl="0" eaLnBrk="1" latinLnBrk="0" hangingPunct="1">
+        <a:defRPr sz="1273" kern="1200">
           <a:solidFill>
             <a:schemeClr val="tx1"/>
           </a:solidFill>
@@ -806,8 +806,8 @@
           <a:cs typeface="+mn-cs"/>
         </a:defRPr>
       </a:lvl5pPr>
-      <a:lvl6pPr marL="2286000" algn="l" defTabSz="914400" rtl="0" eaLnBrk="1" latinLnBrk="0" hangingPunct="1">
-        <a:defRPr sz="1800" kern="1200">
+      <a:lvl6pPr marL="1616364" algn="l" defTabSz="914400" rtl="0" eaLnBrk="1" latinLnBrk="0" hangingPunct="1">
+        <a:defRPr sz="1273" kern="1200">
           <a:solidFill>
             <a:schemeClr val="tx1"/>
           </a:solidFill>
@@ -816,8 +816,8 @@
           <a:cs typeface="+mn-cs"/>
         </a:defRPr>
       </a:lvl6pPr>
-      <a:lvl7pPr marL="2743200" algn="l" defTabSz="914400" rtl="0" eaLnBrk="1" latinLnBrk="0" hangingPunct="1">
-        <a:defRPr sz="1800" kern="1200">
+      <a:lvl7pPr marL="1939636" algn="l" defTabSz="914400" rtl="0" eaLnBrk="1" latinLnBrk="0" hangingPunct="1">
+        <a:defRPr sz="1273" kern="1200">
           <a:solidFill>
             <a:schemeClr val="tx1"/>
           </a:solidFill>
@@ -826,8 +826,8 @@
           <a:cs typeface="+mn-cs"/>
         </a:defRPr>
       </a:lvl7pPr>
-      <a:lvl8pPr marL="3200400" algn="l" defTabSz="914400" rtl="0" eaLnBrk="1" latinLnBrk="0" hangingPunct="1">
-        <a:defRPr sz="1800" kern="1200">
+      <a:lvl8pPr marL="2262909" algn="l" defTabSz="914400" rtl="0" eaLnBrk="1" latinLnBrk="0" hangingPunct="1">
+        <a:defRPr sz="1273" kern="1200">
           <a:solidFill>
             <a:schemeClr val="tx1"/>
           </a:solidFill>
@@ -836,8 +836,8 @@
           <a:cs typeface="+mn-cs"/>
         </a:defRPr>
       </a:lvl8pPr>
-      <a:lvl9pPr marL="3657600" algn="l" defTabSz="914400" rtl="0" eaLnBrk="1" latinLnBrk="0" hangingPunct="1">
-        <a:defRPr sz="1800" kern="1200">
+      <a:lvl9pPr marL="2586182" algn="l" defTabSz="914400" rtl="0" eaLnBrk="1" latinLnBrk="0" hangingPunct="1">
+        <a:defRPr sz="1273" kern="1200">
           <a:solidFill>
             <a:schemeClr val="tx1"/>
           </a:solidFill>
@@ -884,7 +884,7 @@
         <p:spPr>
           <a:xfrm>
             <a:off x="0" y="0"/>
-            <a:ext cx="21384158" cy="30275784"/>
+            <a:ext cx="15120112" cy="21407120"/>
           </a:xfrm>
           <a:prstGeom prst="rect">
             <a:avLst/>
@@ -892,7 +892,7 @@
           <a:solidFill>
             <a:srgbClr val="F6FAFD"/>
           </a:solidFill>
-          <a:ln w="12700">
+          <a:ln w="8980">
             <a:solidFill>
               <a:srgbClr val="F6FAFD">
                 <a:alpha val="0"/>
@@ -911,7 +911,7 @@
         <p:spPr>
           <a:xfrm>
             <a:off x="0" y="0"/>
-            <a:ext cx="21384158" cy="2834640"/>
+            <a:ext cx="15120112" cy="2004291"/>
           </a:xfrm>
           <a:prstGeom prst="rect">
             <a:avLst/>
@@ -919,7 +919,7 @@
           <a:solidFill>
             <a:srgbClr val="061A2D"/>
           </a:solidFill>
-          <a:ln w="12700">
+          <a:ln w="8980">
             <a:solidFill>
               <a:srgbClr val="061A2D">
                 <a:alpha val="0"/>
@@ -937,8 +937,8 @@
         </p:nvSpPr>
         <p:spPr>
           <a:xfrm>
-            <a:off x="0" y="2834640"/>
-            <a:ext cx="21384158" cy="91440"/>
+            <a:off x="0" y="2004291"/>
+            <a:ext cx="15120112" cy="64655"/>
           </a:xfrm>
           <a:prstGeom prst="rect">
             <a:avLst/>
@@ -946,7 +946,7 @@
           <a:solidFill>
             <a:srgbClr val="00C8FF"/>
           </a:solidFill>
-          <a:ln w="12700">
+          <a:ln w="8980">
             <a:solidFill>
               <a:srgbClr val="00C8FF">
                 <a:alpha val="0"/>
@@ -971,8 +971,8 @@
         </p:blipFill>
         <p:spPr>
           <a:xfrm>
-            <a:off x="502920" y="457200"/>
-            <a:ext cx="1078992" cy="1143000"/>
+            <a:off x="355600" y="323273"/>
+            <a:ext cx="762924" cy="808182"/>
           </a:xfrm>
           <a:prstGeom prst="rect">
             <a:avLst/>
@@ -987,8 +987,8 @@
         </p:nvSpPr>
         <p:spPr>
           <a:xfrm>
-            <a:off x="1591056" y="557784"/>
-            <a:ext cx="1143000" cy="868680"/>
+            <a:off x="1124989" y="394393"/>
+            <a:ext cx="808182" cy="614218"/>
           </a:xfrm>
           <a:prstGeom prst="rect">
             <a:avLst/>
@@ -1006,7 +1006,7 @@
               <a:buNone/>
             </a:pPr>
             <a:r>
-              <a:rPr lang="en-US" sz="1500" b="1" dirty="0">
+              <a:rPr lang="en-US" sz="1061" b="1" dirty="0">
                 <a:solidFill>
                   <a:srgbClr val="D7F7FF"/>
                 </a:solidFill>
@@ -1016,14 +1016,14 @@
               </a:rPr>
               <a:t>ULUSAL</a:t>
             </a:r>
-            <a:endParaRPr lang="en-US" sz="1500" dirty="0"/>
-          </a:p>
-          <a:p>
-            <a:pPr indent="0" marL="0">
-              <a:buNone/>
-            </a:pPr>
-            <a:r>
-              <a:rPr lang="en-US" sz="1500" b="1" dirty="0">
+            <a:endParaRPr lang="en-US" sz="1061" dirty="0"/>
+          </a:p>
+          <a:p>
+            <a:pPr indent="0" marL="0">
+              <a:buNone/>
+            </a:pPr>
+            <a:r>
+              <a:rPr lang="en-US" sz="1061" b="1" dirty="0">
                 <a:solidFill>
                   <a:srgbClr val="D7F7FF"/>
                 </a:solidFill>
@@ -1033,14 +1033,14 @@
               </a:rPr>
               <a:t>HİDROJEN</a:t>
             </a:r>
-            <a:endParaRPr lang="en-US" sz="1500" dirty="0"/>
-          </a:p>
-          <a:p>
-            <a:pPr indent="0" marL="0">
-              <a:buNone/>
-            </a:pPr>
-            <a:r>
-              <a:rPr lang="en-US" sz="1500" b="1" dirty="0">
+            <a:endParaRPr lang="en-US" sz="1061" dirty="0"/>
+          </a:p>
+          <a:p>
+            <a:pPr indent="0" marL="0">
+              <a:buNone/>
+            </a:pPr>
+            <a:r>
+              <a:rPr lang="en-US" sz="1061" b="1" dirty="0">
                 <a:solidFill>
                   <a:srgbClr val="D7F7FF"/>
                 </a:solidFill>
@@ -1050,7 +1050,7 @@
               </a:rPr>
               <a:t>ZİRVESİ</a:t>
             </a:r>
-            <a:endParaRPr lang="en-US" sz="1500" dirty="0"/>
+            <a:endParaRPr lang="en-US" sz="1061" dirty="0"/>
           </a:p>
         </p:txBody>
       </p:sp>
@@ -1070,8 +1070,8 @@
         </p:blipFill>
         <p:spPr>
           <a:xfrm>
-            <a:off x="15681960" y="390980"/>
-            <a:ext cx="2468880" cy="1037696"/>
+            <a:off x="11088255" y="276451"/>
+            <a:ext cx="1745673" cy="733724"/>
           </a:xfrm>
           <a:prstGeom prst="rect">
             <a:avLst/>
@@ -1093,8 +1093,8 @@
         </p:blipFill>
         <p:spPr>
           <a:xfrm>
-            <a:off x="18288000" y="384048"/>
-            <a:ext cx="2651760" cy="1051560"/>
+            <a:off x="12930909" y="271549"/>
+            <a:ext cx="1874982" cy="743527"/>
           </a:xfrm>
           <a:prstGeom prst="rect">
             <a:avLst/>
@@ -1109,8 +1109,8 @@
         </p:nvSpPr>
         <p:spPr>
           <a:xfrm>
-            <a:off x="3063240" y="420624"/>
-            <a:ext cx="12252960" cy="749808"/>
+            <a:off x="2165927" y="297411"/>
+            <a:ext cx="8663709" cy="530167"/>
           </a:xfrm>
           <a:prstGeom prst="rect">
             <a:avLst/>
@@ -1128,7 +1128,7 @@
               <a:buNone/>
             </a:pPr>
             <a:r>
-              <a:rPr lang="en-US" sz="4600" b="1" dirty="0">
+              <a:rPr lang="en-US" sz="3253" b="1" dirty="0">
                 <a:solidFill>
                   <a:srgbClr val="FFFFFF"/>
                 </a:solidFill>
@@ -1138,7 +1138,7 @@
               </a:rPr>
               <a:t>TÜRKİYE HİDROJEN ZİRVESİ 2026</a:t>
             </a:r>
-            <a:endParaRPr lang="en-US" sz="4600" dirty="0"/>
+            <a:endParaRPr lang="en-US" sz="3253" dirty="0"/>
           </a:p>
         </p:txBody>
       </p:sp>
@@ -1150,8 +1150,8 @@
         </p:nvSpPr>
         <p:spPr>
           <a:xfrm>
-            <a:off x="3063240" y="1207008"/>
-            <a:ext cx="10515600" cy="384048"/>
+            <a:off x="2165927" y="853440"/>
+            <a:ext cx="7435273" cy="271549"/>
           </a:xfrm>
           <a:prstGeom prst="rect">
             <a:avLst/>
@@ -1169,7 +1169,7 @@
               <a:buNone/>
             </a:pPr>
             <a:r>
-              <a:rPr lang="en-US" sz="2300" dirty="0">
+              <a:rPr lang="en-US" sz="1626" dirty="0">
                 <a:solidFill>
                   <a:srgbClr val="D7F7FF"/>
                 </a:solidFill>
@@ -1179,7 +1179,7 @@
               </a:rPr>
               <a:t>Akademik ve Endüstriyel Poster Sunum Şablonu</a:t>
             </a:r>
-            <a:endParaRPr lang="en-US" sz="2300" dirty="0"/>
+            <a:endParaRPr lang="en-US" sz="1626" dirty="0"/>
           </a:p>
         </p:txBody>
       </p:sp>
@@ -1191,8 +1191,8 @@
         </p:nvSpPr>
         <p:spPr>
           <a:xfrm>
-            <a:off x="3063240" y="1709928"/>
-            <a:ext cx="10698480" cy="393192"/>
+            <a:off x="2165927" y="1209040"/>
+            <a:ext cx="7564582" cy="278015"/>
           </a:xfrm>
           <a:prstGeom prst="rect">
             <a:avLst/>
@@ -1210,7 +1210,7 @@
               <a:buNone/>
             </a:pPr>
             <a:r>
-              <a:rPr lang="en-US" sz="2400" b="1" dirty="0">
+              <a:rPr lang="en-US" sz="1697" b="1" dirty="0">
                 <a:solidFill>
                   <a:srgbClr val="00C8FF"/>
                 </a:solidFill>
@@ -1220,7 +1220,7 @@
               </a:rPr>
               <a:t>15-16 EKİM 2026  ·  ATO CONGRESIUM  ·  ANKARA</a:t>
             </a:r>
-            <a:endParaRPr lang="en-US" sz="2400" dirty="0"/>
+            <a:endParaRPr lang="en-US" sz="1697" dirty="0"/>
           </a:p>
         </p:txBody>
       </p:sp>
@@ -1232,8 +1232,8 @@
         </p:nvSpPr>
         <p:spPr>
           <a:xfrm>
-            <a:off x="3063240" y="2139696"/>
-            <a:ext cx="11612880" cy="347472"/>
+            <a:off x="2165927" y="1512916"/>
+            <a:ext cx="8211127" cy="245687"/>
           </a:xfrm>
           <a:prstGeom prst="rect">
             <a:avLst/>
@@ -1251,7 +1251,7 @@
               <a:buNone/>
             </a:pPr>
             <a:r>
-              <a:rPr lang="en-US" sz="2000" dirty="0">
+              <a:rPr lang="en-US" sz="1414" dirty="0">
                 <a:solidFill>
                   <a:srgbClr val="B7DCE9"/>
                 </a:solidFill>
@@ -1261,7 +1261,7 @@
               </a:rPr>
               <a:t>A1 DİKEY  ·  Türkçe / English  ·  Minimum 28 pt</a:t>
             </a:r>
-            <a:endParaRPr lang="en-US" sz="2000" dirty="0"/>
+            <a:endParaRPr lang="en-US" sz="1414" dirty="0"/>
           </a:p>
         </p:txBody>
       </p:sp>
@@ -1273,8 +1273,8 @@
         </p:nvSpPr>
         <p:spPr>
           <a:xfrm>
-            <a:off x="594360" y="3246120"/>
-            <a:ext cx="20208240" cy="2148840"/>
+            <a:off x="420255" y="2295236"/>
+            <a:ext cx="14288655" cy="1519382"/>
           </a:xfrm>
           <a:prstGeom prst="roundRect">
             <a:avLst>
@@ -1284,7 +1284,7 @@
           <a:solidFill>
             <a:srgbClr val="FFFFFF"/>
           </a:solidFill>
-          <a:ln w="12700">
+          <a:ln w="8980">
             <a:solidFill>
               <a:srgbClr val="CBE3EF"/>
             </a:solidFill>
@@ -1300,8 +1300,8 @@
         </p:nvSpPr>
         <p:spPr>
           <a:xfrm>
-            <a:off x="868680" y="3429000"/>
-            <a:ext cx="19659600" cy="713232"/>
+            <a:off x="614218" y="2424545"/>
+            <a:ext cx="13900727" cy="504305"/>
           </a:xfrm>
           <a:prstGeom prst="rect">
             <a:avLst/>
@@ -1319,7 +1319,7 @@
               <a:buNone/>
             </a:pPr>
             <a:r>
-              <a:rPr lang="en-US" sz="4400" b="1" dirty="0">
+              <a:rPr lang="en-US" sz="3111" b="1" dirty="0">
                 <a:solidFill>
                   <a:srgbClr val="102033"/>
                 </a:solidFill>
@@ -1329,7 +1329,7 @@
               </a:rPr>
               <a:t>POSTER BAŞLIĞI: ÇALIŞMANIN KISA, NET VE TEKNİK BAŞLIĞI</a:t>
             </a:r>
-            <a:endParaRPr lang="en-US" sz="4400" dirty="0"/>
+            <a:endParaRPr lang="en-US" sz="3111" dirty="0"/>
           </a:p>
         </p:txBody>
       </p:sp>
@@ -1341,8 +1341,8 @@
         </p:nvSpPr>
         <p:spPr>
           <a:xfrm>
-            <a:off x="1234440" y="4251960"/>
-            <a:ext cx="18836640" cy="365760"/>
+            <a:off x="872836" y="3006436"/>
+            <a:ext cx="13318836" cy="258618"/>
           </a:xfrm>
           <a:prstGeom prst="rect">
             <a:avLst/>
@@ -1360,7 +1360,7 @@
               <a:buNone/>
             </a:pPr>
             <a:r>
-              <a:rPr lang="en-US" sz="2400" dirty="0">
+              <a:rPr lang="en-US" sz="1697" dirty="0">
                 <a:solidFill>
                   <a:srgbClr val="475569"/>
                 </a:solidFill>
@@ -1370,7 +1370,7 @@
               </a:rPr>
               <a:t>Yazar Adları¹,²  ·  Kurum / Şirket  ·  Bölüm / Birim  ·  Şehir, Ülke  ·  e-posta</a:t>
             </a:r>
-            <a:endParaRPr lang="en-US" sz="2400" dirty="0"/>
+            <a:endParaRPr lang="en-US" sz="1697" dirty="0"/>
           </a:p>
         </p:txBody>
       </p:sp>
@@ -1382,8 +1382,8 @@
         </p:nvSpPr>
         <p:spPr>
           <a:xfrm>
-            <a:off x="1234440" y="4700016"/>
-            <a:ext cx="18836640" cy="347472"/>
+            <a:off x="872836" y="3323244"/>
+            <a:ext cx="13318836" cy="245687"/>
           </a:xfrm>
           <a:prstGeom prst="rect">
             <a:avLst/>
@@ -1401,7 +1401,7 @@
               <a:buNone/>
             </a:pPr>
             <a:r>
-              <a:rPr lang="en-US" sz="2300" b="1" dirty="0">
+              <a:rPr lang="en-US" sz="1626" b="1" dirty="0">
                 <a:solidFill>
                   <a:srgbClr val="0F6D87"/>
                 </a:solidFill>
@@ -1411,7 +1411,7 @@
               </a:rPr>
               <a:t>Anahtar Kelimeler: hidrojen üretimi · elektroliz · yakıt hücreleri · depolama · sürdürülebilirlik · TRL</a:t>
             </a:r>
-            <a:endParaRPr lang="en-US" sz="2300" dirty="0"/>
+            <a:endParaRPr lang="en-US" sz="1626" dirty="0"/>
           </a:p>
         </p:txBody>
       </p:sp>
@@ -1423,14 +1423,14 @@
         </p:nvSpPr>
         <p:spPr>
           <a:xfrm>
-            <a:off x="7272833" y="5715000"/>
-            <a:ext cx="0" cy="21717000"/>
+            <a:off x="5142407" y="4040909"/>
+            <a:ext cx="0" cy="15355455"/>
           </a:xfrm>
           <a:prstGeom prst="line">
             <a:avLst/>
           </a:prstGeom>
           <a:noFill/>
-          <a:ln w="12700">
+          <a:ln w="8980">
             <a:solidFill>
               <a:srgbClr val="D2E8F1"/>
             </a:solidFill>
@@ -1446,14 +1446,14 @@
         </p:nvSpPr>
         <p:spPr>
           <a:xfrm>
-            <a:off x="14111326" y="5715000"/>
-            <a:ext cx="0" cy="21717000"/>
+            <a:off x="9977705" y="4040909"/>
+            <a:ext cx="0" cy="15355455"/>
           </a:xfrm>
           <a:prstGeom prst="line">
             <a:avLst/>
           </a:prstGeom>
           <a:noFill/>
-          <a:ln w="12700">
+          <a:ln w="8980">
             <a:solidFill>
               <a:srgbClr val="D2E8F1"/>
             </a:solidFill>
@@ -1469,8 +1469,8 @@
         </p:nvSpPr>
         <p:spPr>
           <a:xfrm>
-            <a:off x="594360" y="5715000"/>
-            <a:ext cx="6518453" cy="530352"/>
+            <a:off x="420255" y="4040909"/>
+            <a:ext cx="4609007" cy="374996"/>
           </a:xfrm>
           <a:prstGeom prst="rect">
             <a:avLst/>
@@ -1487,7 +1487,7 @@
           </a:ln>
         </p:spPr>
         <p:txBody>
-          <a:bodyPr wrap="square" lIns="1651" tIns="1651" rIns="1651" bIns="1651" rtlCol="0" anchor="ctr">
+          <a:bodyPr wrap="square" lIns="1167" tIns="1167" rIns="1167" bIns="1167" rtlCol="0" anchor="ctr">
             <a:normAutofit/>
           </a:bodyPr>
           <a:lstStyle/>
@@ -1496,7 +1496,7 @@
               <a:buNone/>
             </a:pPr>
             <a:r>
-              <a:rPr lang="en-US" sz="3000" b="1" dirty="0">
+              <a:rPr lang="en-US" sz="2121" b="1" dirty="0">
                 <a:solidFill>
                   <a:srgbClr val="FFFFFF"/>
                 </a:solidFill>
@@ -1506,7 +1506,7 @@
               </a:rPr>
               <a:t>01  GİRİŞ VE MOTİVASYON</a:t>
             </a:r>
-            <a:endParaRPr lang="en-US" sz="3000" dirty="0"/>
+            <a:endParaRPr lang="en-US" sz="2121" dirty="0"/>
           </a:p>
         </p:txBody>
       </p:sp>
@@ -1518,8 +1518,8 @@
         </p:nvSpPr>
         <p:spPr>
           <a:xfrm>
-            <a:off x="594360" y="6300216"/>
-            <a:ext cx="6518453" cy="3118104"/>
+            <a:off x="420255" y="4454698"/>
+            <a:ext cx="4609007" cy="2204720"/>
           </a:xfrm>
           <a:prstGeom prst="rect">
             <a:avLst/>
@@ -1527,14 +1527,14 @@
           <a:solidFill>
             <a:srgbClr val="FFFFFF"/>
           </a:solidFill>
-          <a:ln w="13970">
+          <a:ln w="9878">
             <a:solidFill>
               <a:srgbClr val="B9D7E5"/>
             </a:solidFill>
           </a:ln>
         </p:spPr>
         <p:txBody>
-          <a:bodyPr wrap="square" lIns="2286" tIns="2286" rIns="2286" bIns="2286" rtlCol="0" anchor="t">
+          <a:bodyPr wrap="square" lIns="1616" tIns="1616" rIns="1616" bIns="1616" rtlCol="0" anchor="t">
             <a:normAutofit/>
           </a:bodyPr>
           <a:lstStyle/>
@@ -1543,7 +1543,7 @@
               <a:buNone/>
             </a:pPr>
             <a:r>
-              <a:rPr lang="en-US" sz="2800" dirty="0">
+              <a:rPr lang="en-US" sz="1980" dirty="0">
                 <a:solidFill>
                   <a:srgbClr val="1E293B"/>
                 </a:solidFill>
@@ -1553,14 +1553,14 @@
               </a:rPr>
               <a:t>• Çalışmanın bağlamını ve hidrojen teknolojileriyle ilişkisini 3-4 cümlede özetleyin.</a:t>
             </a:r>
-            <a:endParaRPr lang="en-US" sz="2800" dirty="0"/>
-          </a:p>
-          <a:p>
-            <a:pPr indent="0" marL="0">
-              <a:buNone/>
-            </a:pPr>
-            <a:r>
-              <a:rPr lang="en-US" sz="2800" dirty="0">
+            <a:endParaRPr lang="en-US" sz="1980" dirty="0"/>
+          </a:p>
+          <a:p>
+            <a:pPr indent="0" marL="0">
+              <a:buNone/>
+            </a:pPr>
+            <a:r>
+              <a:rPr lang="en-US" sz="1980" dirty="0">
                 <a:solidFill>
                   <a:srgbClr val="1E293B"/>
                 </a:solidFill>
@@ -1570,14 +1570,14 @@
               </a:rPr>
               <a:t>• Problemi net kurun: hangi teknik, ekonomik veya çevresel boşluğu hedefliyorsunuz?</a:t>
             </a:r>
-            <a:endParaRPr lang="en-US" sz="2800" dirty="0"/>
-          </a:p>
-          <a:p>
-            <a:pPr indent="0" marL="0">
-              <a:buNone/>
-            </a:pPr>
-            <a:r>
-              <a:rPr lang="en-US" sz="2800" dirty="0">
+            <a:endParaRPr lang="en-US" sz="1980" dirty="0"/>
+          </a:p>
+          <a:p>
+            <a:pPr indent="0" marL="0">
+              <a:buNone/>
+            </a:pPr>
+            <a:r>
+              <a:rPr lang="en-US" sz="1980" dirty="0">
                 <a:solidFill>
                   <a:srgbClr val="1E293B"/>
                 </a:solidFill>
@@ -1587,7 +1587,7 @@
               </a:rPr>
               <a:t>• Literatürdeki mevcut yaklaşımı ve bu çalışmanın neden gerekli olduğunu belirtin.</a:t>
             </a:r>
-            <a:endParaRPr lang="en-US" sz="2800" dirty="0"/>
+            <a:endParaRPr lang="en-US" sz="1980" dirty="0"/>
           </a:p>
         </p:txBody>
       </p:sp>
@@ -1599,8 +1599,8 @@
         </p:nvSpPr>
         <p:spPr>
           <a:xfrm>
-            <a:off x="594360" y="9692640"/>
-            <a:ext cx="6518453" cy="530352"/>
+            <a:off x="420255" y="6853382"/>
+            <a:ext cx="4609007" cy="374996"/>
           </a:xfrm>
           <a:prstGeom prst="rect">
             <a:avLst/>
@@ -1617,7 +1617,7 @@
           </a:ln>
         </p:spPr>
         <p:txBody>
-          <a:bodyPr wrap="square" lIns="1651" tIns="1651" rIns="1651" bIns="1651" rtlCol="0" anchor="ctr">
+          <a:bodyPr wrap="square" lIns="1167" tIns="1167" rIns="1167" bIns="1167" rtlCol="0" anchor="ctr">
             <a:normAutofit/>
           </a:bodyPr>
           <a:lstStyle/>
@@ -1626,7 +1626,7 @@
               <a:buNone/>
             </a:pPr>
             <a:r>
-              <a:rPr lang="en-US" sz="3000" b="1" dirty="0">
+              <a:rPr lang="en-US" sz="2121" b="1" dirty="0">
                 <a:solidFill>
                   <a:srgbClr val="FFFFFF"/>
                 </a:solidFill>
@@ -1636,7 +1636,7 @@
               </a:rPr>
               <a:t>02  AMAÇ &amp; ÖZGÜN KATKI</a:t>
             </a:r>
-            <a:endParaRPr lang="en-US" sz="3000" dirty="0"/>
+            <a:endParaRPr lang="en-US" sz="2121" dirty="0"/>
           </a:p>
         </p:txBody>
       </p:sp>
@@ -1648,8 +1648,8 @@
         </p:nvSpPr>
         <p:spPr>
           <a:xfrm>
-            <a:off x="594360" y="10277856"/>
-            <a:ext cx="6518453" cy="4032504"/>
+            <a:off x="420255" y="7267171"/>
+            <a:ext cx="4609007" cy="2851265"/>
           </a:xfrm>
           <a:prstGeom prst="rect">
             <a:avLst/>
@@ -1657,14 +1657,14 @@
           <a:solidFill>
             <a:srgbClr val="FFFFFF"/>
           </a:solidFill>
-          <a:ln w="13970">
+          <a:ln w="9878">
             <a:solidFill>
               <a:srgbClr val="B9D7E5"/>
             </a:solidFill>
           </a:ln>
         </p:spPr>
         <p:txBody>
-          <a:bodyPr wrap="square" lIns="2286" tIns="2286" rIns="2286" bIns="2286" rtlCol="0" anchor="t">
+          <a:bodyPr wrap="square" lIns="1616" tIns="1616" rIns="1616" bIns="1616" rtlCol="0" anchor="t">
             <a:normAutofit/>
           </a:bodyPr>
           <a:lstStyle/>
@@ -1673,7 +1673,7 @@
               <a:buNone/>
             </a:pPr>
             <a:r>
-              <a:rPr lang="en-US" sz="2750" dirty="0">
+              <a:rPr lang="en-US" sz="1944" dirty="0">
                 <a:solidFill>
                   <a:srgbClr val="1E293B"/>
                 </a:solidFill>
@@ -1683,20 +1683,20 @@
               </a:rPr>
               <a:t>Amaç: Bu çalışmanın amacı, … hidrojen teknolojisi kapsamında … performansını değerlendirmektir.</a:t>
             </a:r>
-            <a:endParaRPr lang="en-US" sz="2750" dirty="0"/>
-          </a:p>
-          <a:p>
-            <a:pPr indent="0" marL="0">
-              <a:buNone/>
-            </a:pPr>
-            <a:endParaRPr lang="en-US" sz="2750" dirty="0"/>
-          </a:p>
-          <a:p>
-            <a:pPr indent="0" marL="0">
-              <a:buNone/>
-            </a:pPr>
-            <a:r>
-              <a:rPr lang="en-US" sz="2750" dirty="0">
+            <a:endParaRPr lang="en-US" sz="1944" dirty="0"/>
+          </a:p>
+          <a:p>
+            <a:pPr indent="0" marL="0">
+              <a:buNone/>
+            </a:pPr>
+            <a:endParaRPr lang="en-US" sz="1944" dirty="0"/>
+          </a:p>
+          <a:p>
+            <a:pPr indent="0" marL="0">
+              <a:buNone/>
+            </a:pPr>
+            <a:r>
+              <a:rPr lang="en-US" sz="1944" dirty="0">
                 <a:solidFill>
                   <a:srgbClr val="1E293B"/>
                 </a:solidFill>
@@ -1706,20 +1706,20 @@
               </a:rPr>
               <a:t>Özgün Katkı: Çalışma, … parametresini / yöntemi / uygulama alanını literatürdeki benzer çalışmalardan farklı biçimde ele almaktadır.</a:t>
             </a:r>
-            <a:endParaRPr lang="en-US" sz="2750" dirty="0"/>
-          </a:p>
-          <a:p>
-            <a:pPr indent="0" marL="0">
-              <a:buNone/>
-            </a:pPr>
-            <a:endParaRPr lang="en-US" sz="2750" dirty="0"/>
-          </a:p>
-          <a:p>
-            <a:pPr indent="0" marL="0">
-              <a:buNone/>
-            </a:pPr>
-            <a:r>
-              <a:rPr lang="en-US" sz="2750" dirty="0">
+            <a:endParaRPr lang="en-US" sz="1944" dirty="0"/>
+          </a:p>
+          <a:p>
+            <a:pPr indent="0" marL="0">
+              <a:buNone/>
+            </a:pPr>
+            <a:endParaRPr lang="en-US" sz="1944" dirty="0"/>
+          </a:p>
+          <a:p>
+            <a:pPr indent="0" marL="0">
+              <a:buNone/>
+            </a:pPr>
+            <a:r>
+              <a:rPr lang="en-US" sz="1944" dirty="0">
                 <a:solidFill>
                   <a:srgbClr val="1E293B"/>
                 </a:solidFill>
@@ -1729,7 +1729,7 @@
               </a:rPr>
               <a:t>Jüri için tek cümlelik katkı: “Bu posterin en önemli bulgusu …”</a:t>
             </a:r>
-            <a:endParaRPr lang="en-US" sz="2750" dirty="0"/>
+            <a:endParaRPr lang="en-US" sz="1944" dirty="0"/>
           </a:p>
         </p:txBody>
       </p:sp>
@@ -1741,8 +1741,8 @@
         </p:nvSpPr>
         <p:spPr>
           <a:xfrm>
-            <a:off x="594360" y="14584680"/>
-            <a:ext cx="6518453" cy="530352"/>
+            <a:off x="420255" y="10312400"/>
+            <a:ext cx="4609007" cy="374996"/>
           </a:xfrm>
           <a:prstGeom prst="rect">
             <a:avLst/>
@@ -1759,7 +1759,7 @@
           </a:ln>
         </p:spPr>
         <p:txBody>
-          <a:bodyPr wrap="square" lIns="1651" tIns="1651" rIns="1651" bIns="1651" rtlCol="0" anchor="ctr">
+          <a:bodyPr wrap="square" lIns="1167" tIns="1167" rIns="1167" bIns="1167" rtlCol="0" anchor="ctr">
             <a:normAutofit/>
           </a:bodyPr>
           <a:lstStyle/>
@@ -1768,7 +1768,7 @@
               <a:buNone/>
             </a:pPr>
             <a:r>
-              <a:rPr lang="en-US" sz="3000" b="1" dirty="0">
+              <a:rPr lang="en-US" sz="2121" b="1" dirty="0">
                 <a:solidFill>
                   <a:srgbClr val="FFFFFF"/>
                 </a:solidFill>
@@ -1778,7 +1778,7 @@
               </a:rPr>
               <a:t>03  HİDROJEN DEĞER ZİNCİRİ</a:t>
             </a:r>
-            <a:endParaRPr lang="en-US" sz="3000" dirty="0"/>
+            <a:endParaRPr lang="en-US" sz="2121" dirty="0"/>
           </a:p>
         </p:txBody>
       </p:sp>
@@ -1790,8 +1790,8 @@
         </p:nvSpPr>
         <p:spPr>
           <a:xfrm>
-            <a:off x="594360" y="15169896"/>
-            <a:ext cx="6518453" cy="1005840"/>
+            <a:off x="420255" y="10726189"/>
+            <a:ext cx="4609007" cy="711200"/>
           </a:xfrm>
           <a:prstGeom prst="rect">
             <a:avLst/>
@@ -1799,14 +1799,14 @@
           <a:solidFill>
             <a:srgbClr val="FFFFFF"/>
           </a:solidFill>
-          <a:ln w="13970">
+          <a:ln w="9878">
             <a:solidFill>
               <a:srgbClr val="B9D7E5"/>
             </a:solidFill>
           </a:ln>
         </p:spPr>
         <p:txBody>
-          <a:bodyPr wrap="square" lIns="2286" tIns="2286" rIns="2286" bIns="2286" rtlCol="0" anchor="t">
+          <a:bodyPr wrap="square" lIns="1616" tIns="1616" rIns="1616" bIns="1616" rtlCol="0" anchor="t">
             <a:normAutofit/>
           </a:bodyPr>
           <a:lstStyle/>
@@ -1815,7 +1815,7 @@
               <a:buNone/>
             </a:pPr>
             <a:r>
-              <a:rPr lang="en-US" sz="2650" dirty="0">
+              <a:rPr lang="en-US" sz="1874" dirty="0">
                 <a:solidFill>
                   <a:srgbClr val="1E293B"/>
                 </a:solidFill>
@@ -1825,7 +1825,7 @@
               </a:rPr>
               <a:t>Çalışmanın değer zincirindeki yerini işaretleyin: üretim, depolama, taşıma, kullanım, sistem entegrasyonu veya politika/strateji.</a:t>
             </a:r>
-            <a:endParaRPr lang="en-US" sz="2650" dirty="0"/>
+            <a:endParaRPr lang="en-US" sz="1874" dirty="0"/>
           </a:p>
         </p:txBody>
       </p:sp>
@@ -1844,8 +1844,8 @@
         </p:blipFill>
         <p:spPr>
           <a:xfrm>
-            <a:off x="594360" y="16303752"/>
-            <a:ext cx="6518453" cy="2423160"/>
+            <a:off x="420255" y="11527905"/>
+            <a:ext cx="4609007" cy="1713345"/>
           </a:xfrm>
           <a:prstGeom prst="rect">
             <a:avLst/>
@@ -1860,8 +1860,8 @@
         </p:nvSpPr>
         <p:spPr>
           <a:xfrm>
-            <a:off x="594360" y="18772632"/>
-            <a:ext cx="6518453" cy="301752"/>
+            <a:off x="420255" y="13273578"/>
+            <a:ext cx="4609007" cy="213360"/>
           </a:xfrm>
           <a:prstGeom prst="rect">
             <a:avLst/>
@@ -1877,7 +1877,7 @@
               <a:buNone/>
             </a:pPr>
             <a:r>
-              <a:rPr lang="en-US" sz="1600" i="1" dirty="0">
+              <a:rPr lang="en-US" sz="1131" i="1" dirty="0">
                 <a:solidFill>
                   <a:srgbClr val="475569"/>
                 </a:solidFill>
@@ -1887,7 +1887,7 @@
               </a:rPr>
               <a:t>Şekil alanı: konuya özel sistem / proses / değer zinciri görseli</a:t>
             </a:r>
-            <a:endParaRPr lang="en-US" sz="1600" dirty="0"/>
+            <a:endParaRPr lang="en-US" sz="1131" dirty="0"/>
           </a:p>
         </p:txBody>
       </p:sp>
@@ -1899,8 +1899,8 @@
         </p:nvSpPr>
         <p:spPr>
           <a:xfrm>
-            <a:off x="594360" y="19339560"/>
-            <a:ext cx="6518453" cy="530352"/>
+            <a:off x="420255" y="13674436"/>
+            <a:ext cx="4609007" cy="374996"/>
           </a:xfrm>
           <a:prstGeom prst="rect">
             <a:avLst/>
@@ -1917,7 +1917,7 @@
           </a:ln>
         </p:spPr>
         <p:txBody>
-          <a:bodyPr wrap="square" lIns="1651" tIns="1651" rIns="1651" bIns="1651" rtlCol="0" anchor="ctr">
+          <a:bodyPr wrap="square" lIns="1167" tIns="1167" rIns="1167" bIns="1167" rtlCol="0" anchor="ctr">
             <a:normAutofit/>
           </a:bodyPr>
           <a:lstStyle/>
@@ -1926,7 +1926,7 @@
               <a:buNone/>
             </a:pPr>
             <a:r>
-              <a:rPr lang="en-US" sz="3000" b="1" dirty="0">
+              <a:rPr lang="en-US" sz="2121" b="1" dirty="0">
                 <a:solidFill>
                   <a:srgbClr val="FFFFFF"/>
                 </a:solidFill>
@@ -1936,7 +1936,7 @@
               </a:rPr>
               <a:t>04  KAPSAM / TRL / VERİ SETİ</a:t>
             </a:r>
-            <a:endParaRPr lang="en-US" sz="3000" dirty="0"/>
+            <a:endParaRPr lang="en-US" sz="2121" dirty="0"/>
           </a:p>
         </p:txBody>
       </p:sp>
@@ -1948,8 +1948,8 @@
         </p:nvSpPr>
         <p:spPr>
           <a:xfrm>
-            <a:off x="594360" y="19924776"/>
-            <a:ext cx="6518453" cy="4398264"/>
+            <a:off x="420255" y="14088225"/>
+            <a:ext cx="4609007" cy="3109884"/>
           </a:xfrm>
           <a:prstGeom prst="rect">
             <a:avLst/>
@@ -1957,14 +1957,14 @@
           <a:solidFill>
             <a:srgbClr val="FFFFFF"/>
           </a:solidFill>
-          <a:ln w="13970">
+          <a:ln w="9878">
             <a:solidFill>
               <a:srgbClr val="B9D7E5"/>
             </a:solidFill>
           </a:ln>
         </p:spPr>
         <p:txBody>
-          <a:bodyPr wrap="square" lIns="2286" tIns="2286" rIns="2286" bIns="2286" rtlCol="0" anchor="t">
+          <a:bodyPr wrap="square" lIns="1616" tIns="1616" rIns="1616" bIns="1616" rtlCol="0" anchor="t">
             <a:normAutofit/>
           </a:bodyPr>
           <a:lstStyle/>
@@ -1973,7 +1973,7 @@
               <a:buNone/>
             </a:pPr>
             <a:r>
-              <a:rPr lang="en-US" sz="2750" dirty="0">
+              <a:rPr lang="en-US" sz="1944" dirty="0">
                 <a:solidFill>
                   <a:srgbClr val="1E293B"/>
                 </a:solidFill>
@@ -1983,20 +1983,20 @@
               </a:rPr>
               <a:t>Çalışma Alanı: üretim, depolama, yakıt hücresi, endüstriyel uygulama, sistem entegrasyonu vb.</a:t>
             </a:r>
-            <a:endParaRPr lang="en-US" sz="2750" dirty="0"/>
-          </a:p>
-          <a:p>
-            <a:pPr indent="0" marL="0">
-              <a:buNone/>
-            </a:pPr>
-            <a:endParaRPr lang="en-US" sz="2750" dirty="0"/>
-          </a:p>
-          <a:p>
-            <a:pPr indent="0" marL="0">
-              <a:buNone/>
-            </a:pPr>
-            <a:r>
-              <a:rPr lang="en-US" sz="2750" dirty="0">
+            <a:endParaRPr lang="en-US" sz="1944" dirty="0"/>
+          </a:p>
+          <a:p>
+            <a:pPr indent="0" marL="0">
+              <a:buNone/>
+            </a:pPr>
+            <a:endParaRPr lang="en-US" sz="1944" dirty="0"/>
+          </a:p>
+          <a:p>
+            <a:pPr indent="0" marL="0">
+              <a:buNone/>
+            </a:pPr>
+            <a:r>
+              <a:rPr lang="en-US" sz="1944" dirty="0">
                 <a:solidFill>
                   <a:srgbClr val="1E293B"/>
                 </a:solidFill>
@@ -2006,20 +2006,20 @@
               </a:rPr>
               <a:t>Teknoloji Hazırlık Seviyesi: TRL 1-3 / TRL 4-6 / TRL 7-9</a:t>
             </a:r>
-            <a:endParaRPr lang="en-US" sz="2750" dirty="0"/>
-          </a:p>
-          <a:p>
-            <a:pPr indent="0" marL="0">
-              <a:buNone/>
-            </a:pPr>
-            <a:endParaRPr lang="en-US" sz="2750" dirty="0"/>
-          </a:p>
-          <a:p>
-            <a:pPr indent="0" marL="0">
-              <a:buNone/>
-            </a:pPr>
-            <a:r>
-              <a:rPr lang="en-US" sz="2750" dirty="0">
+            <a:endParaRPr lang="en-US" sz="1944" dirty="0"/>
+          </a:p>
+          <a:p>
+            <a:pPr indent="0" marL="0">
+              <a:buNone/>
+            </a:pPr>
+            <a:endParaRPr lang="en-US" sz="1944" dirty="0"/>
+          </a:p>
+          <a:p>
+            <a:pPr indent="0" marL="0">
+              <a:buNone/>
+            </a:pPr>
+            <a:r>
+              <a:rPr lang="en-US" sz="1944" dirty="0">
                 <a:solidFill>
                   <a:srgbClr val="1E293B"/>
                 </a:solidFill>
@@ -2029,7 +2029,7 @@
               </a:rPr>
               <a:t>Veri Kaynağı: deneysel ölçüm, simülasyon, saha verisi, literatür karşılaştırması veya analitik model.</a:t>
             </a:r>
-            <a:endParaRPr lang="en-US" sz="2750" dirty="0"/>
+            <a:endParaRPr lang="en-US" sz="1944" dirty="0"/>
           </a:p>
         </p:txBody>
       </p:sp>
@@ -2041,8 +2041,8 @@
         </p:nvSpPr>
         <p:spPr>
           <a:xfrm>
-            <a:off x="7432853" y="5715000"/>
-            <a:ext cx="6518453" cy="530352"/>
+            <a:off x="5255553" y="4040909"/>
+            <a:ext cx="4609007" cy="374996"/>
           </a:xfrm>
           <a:prstGeom prst="rect">
             <a:avLst/>
@@ -2059,7 +2059,7 @@
           </a:ln>
         </p:spPr>
         <p:txBody>
-          <a:bodyPr wrap="square" lIns="1651" tIns="1651" rIns="1651" bIns="1651" rtlCol="0" anchor="ctr">
+          <a:bodyPr wrap="square" lIns="1167" tIns="1167" rIns="1167" bIns="1167" rtlCol="0" anchor="ctr">
             <a:normAutofit/>
           </a:bodyPr>
           <a:lstStyle/>
@@ -2068,7 +2068,7 @@
               <a:buNone/>
             </a:pPr>
             <a:r>
-              <a:rPr lang="en-US" sz="3000" b="1" dirty="0">
+              <a:rPr lang="en-US" sz="2121" b="1" dirty="0">
                 <a:solidFill>
                   <a:srgbClr val="FFFFFF"/>
                 </a:solidFill>
@@ -2078,7 +2078,7 @@
               </a:rPr>
               <a:t>05  YÖNTEM</a:t>
             </a:r>
-            <a:endParaRPr lang="en-US" sz="3000" dirty="0"/>
+            <a:endParaRPr lang="en-US" sz="2121" dirty="0"/>
           </a:p>
         </p:txBody>
       </p:sp>
@@ -2090,8 +2090,8 @@
         </p:nvSpPr>
         <p:spPr>
           <a:xfrm>
-            <a:off x="7432853" y="6300216"/>
-            <a:ext cx="6518453" cy="2798064"/>
+            <a:off x="5255553" y="4454698"/>
+            <a:ext cx="4609007" cy="1978429"/>
           </a:xfrm>
           <a:prstGeom prst="rect">
             <a:avLst/>
@@ -2099,14 +2099,14 @@
           <a:solidFill>
             <a:srgbClr val="FFFFFF"/>
           </a:solidFill>
-          <a:ln w="13970">
+          <a:ln w="9878">
             <a:solidFill>
               <a:srgbClr val="B9D7E5"/>
             </a:solidFill>
           </a:ln>
         </p:spPr>
         <p:txBody>
-          <a:bodyPr wrap="square" lIns="2286" tIns="2286" rIns="2286" bIns="2286" rtlCol="0" anchor="t">
+          <a:bodyPr wrap="square" lIns="1616" tIns="1616" rIns="1616" bIns="1616" rtlCol="0" anchor="t">
             <a:normAutofit/>
           </a:bodyPr>
           <a:lstStyle/>
@@ -2115,7 +2115,7 @@
               <a:buNone/>
             </a:pPr>
             <a:r>
-              <a:rPr lang="en-US" sz="2750" dirty="0">
+              <a:rPr lang="en-US" sz="1944" dirty="0">
                 <a:solidFill>
                   <a:srgbClr val="1E293B"/>
                 </a:solidFill>
@@ -2125,20 +2125,20 @@
               </a:rPr>
               <a:t>Yöntemi bir akış olarak anlatın. Ziyaretçi 10 saniyede çalışmanın nasıl yapıldığını anlayabilmeli.</a:t>
             </a:r>
-            <a:endParaRPr lang="en-US" sz="2750" dirty="0"/>
-          </a:p>
-          <a:p>
-            <a:pPr indent="0" marL="0">
-              <a:buNone/>
-            </a:pPr>
-            <a:endParaRPr lang="en-US" sz="2750" dirty="0"/>
-          </a:p>
-          <a:p>
-            <a:pPr indent="0" marL="0">
-              <a:buNone/>
-            </a:pPr>
-            <a:r>
-              <a:rPr lang="en-US" sz="2750" dirty="0">
+            <a:endParaRPr lang="en-US" sz="1944" dirty="0"/>
+          </a:p>
+          <a:p>
+            <a:pPr indent="0" marL="0">
+              <a:buNone/>
+            </a:pPr>
+            <a:endParaRPr lang="en-US" sz="1944" dirty="0"/>
+          </a:p>
+          <a:p>
+            <a:pPr indent="0" marL="0">
+              <a:buNone/>
+            </a:pPr>
+            <a:r>
+              <a:rPr lang="en-US" sz="1944" dirty="0">
                 <a:solidFill>
                   <a:srgbClr val="1E293B"/>
                 </a:solidFill>
@@ -2148,7 +2148,7 @@
               </a:rPr>
               <a:t>Önerilen sıra: Girdi / hammadde → üretim veya sentez → test / karakterizasyon → veri analizi → değerlendirme.</a:t>
             </a:r>
-            <a:endParaRPr lang="en-US" sz="2750" dirty="0"/>
+            <a:endParaRPr lang="en-US" sz="1944" dirty="0"/>
           </a:p>
         </p:txBody>
       </p:sp>
@@ -2168,8 +2168,8 @@
         </p:blipFill>
         <p:spPr>
           <a:xfrm>
-            <a:off x="8258998" y="9326880"/>
-            <a:ext cx="4866162" cy="3703320"/>
+            <a:off x="5839696" y="6594764"/>
+            <a:ext cx="3440721" cy="2618509"/>
           </a:xfrm>
           <a:prstGeom prst="rect">
             <a:avLst/>
@@ -2184,8 +2184,8 @@
         </p:nvSpPr>
         <p:spPr>
           <a:xfrm>
-            <a:off x="7432853" y="13075920"/>
-            <a:ext cx="6518453" cy="320040"/>
+            <a:off x="5255553" y="9245600"/>
+            <a:ext cx="4609007" cy="226291"/>
           </a:xfrm>
           <a:prstGeom prst="rect">
             <a:avLst/>
@@ -2201,7 +2201,7 @@
               <a:buNone/>
             </a:pPr>
             <a:r>
-              <a:rPr lang="en-US" sz="1600" i="1" dirty="0">
+              <a:rPr lang="en-US" sz="1131" i="1" dirty="0">
                 <a:solidFill>
                   <a:srgbClr val="475569"/>
                 </a:solidFill>
@@ -2211,7 +2211,7 @@
               </a:rPr>
               <a:t>Şekil 1. Yöntem akış şeması ve kullanılan test/analiz teknikleri</a:t>
             </a:r>
-            <a:endParaRPr lang="en-US" sz="1600" dirty="0"/>
+            <a:endParaRPr lang="en-US" sz="1131" dirty="0"/>
           </a:p>
         </p:txBody>
       </p:sp>
@@ -2223,8 +2223,8 @@
         </p:nvSpPr>
         <p:spPr>
           <a:xfrm>
-            <a:off x="7432853" y="13670280"/>
-            <a:ext cx="6518453" cy="530352"/>
+            <a:off x="5255553" y="9665855"/>
+            <a:ext cx="4609007" cy="374996"/>
           </a:xfrm>
           <a:prstGeom prst="rect">
             <a:avLst/>
@@ -2241,7 +2241,7 @@
           </a:ln>
         </p:spPr>
         <p:txBody>
-          <a:bodyPr wrap="square" lIns="1651" tIns="1651" rIns="1651" bIns="1651" rtlCol="0" anchor="ctr">
+          <a:bodyPr wrap="square" lIns="1167" tIns="1167" rIns="1167" bIns="1167" rtlCol="0" anchor="ctr">
             <a:normAutofit/>
           </a:bodyPr>
           <a:lstStyle/>
@@ -2250,7 +2250,7 @@
               <a:buNone/>
             </a:pPr>
             <a:r>
-              <a:rPr lang="en-US" sz="3000" b="1" dirty="0">
+              <a:rPr lang="en-US" sz="2121" b="1" dirty="0">
                 <a:solidFill>
                   <a:srgbClr val="FFFFFF"/>
                 </a:solidFill>
@@ -2260,7 +2260,7 @@
               </a:rPr>
               <a:t>06  DENEY / MODEL / ANALİZ</a:t>
             </a:r>
-            <a:endParaRPr lang="en-US" sz="3000" dirty="0"/>
+            <a:endParaRPr lang="en-US" sz="2121" dirty="0"/>
           </a:p>
         </p:txBody>
       </p:sp>
@@ -2272,8 +2272,8 @@
         </p:nvSpPr>
         <p:spPr>
           <a:xfrm>
-            <a:off x="7432853" y="14255496"/>
-            <a:ext cx="6518453" cy="4718304"/>
+            <a:off x="5255553" y="10079644"/>
+            <a:ext cx="4609007" cy="3336175"/>
           </a:xfrm>
           <a:prstGeom prst="rect">
             <a:avLst/>
@@ -2281,14 +2281,14 @@
           <a:solidFill>
             <a:srgbClr val="FFFFFF"/>
           </a:solidFill>
-          <a:ln w="13970">
+          <a:ln w="9878">
             <a:solidFill>
               <a:srgbClr val="B9D7E5"/>
             </a:solidFill>
           </a:ln>
         </p:spPr>
         <p:txBody>
-          <a:bodyPr wrap="square" lIns="2286" tIns="2286" rIns="2286" bIns="2286" rtlCol="0" anchor="t">
+          <a:bodyPr wrap="square" lIns="1616" tIns="1616" rIns="1616" bIns="1616" rtlCol="0" anchor="t">
             <a:normAutofit/>
           </a:bodyPr>
           <a:lstStyle/>
@@ -2297,7 +2297,7 @@
               <a:buNone/>
             </a:pPr>
             <a:r>
-              <a:rPr lang="en-US" sz="2750" dirty="0">
+              <a:rPr lang="en-US" sz="1944" dirty="0">
                 <a:solidFill>
                   <a:srgbClr val="1E293B"/>
                 </a:solidFill>
@@ -2307,14 +2307,14 @@
               </a:rPr>
               <a:t>Kullanılan altyapıyı kısa ve teknik yazın:</a:t>
             </a:r>
-            <a:endParaRPr lang="en-US" sz="2750" dirty="0"/>
-          </a:p>
-          <a:p>
-            <a:pPr indent="0" marL="0">
-              <a:buNone/>
-            </a:pPr>
-            <a:r>
-              <a:rPr lang="en-US" sz="2750" dirty="0">
+            <a:endParaRPr lang="en-US" sz="1944" dirty="0"/>
+          </a:p>
+          <a:p>
+            <a:pPr indent="0" marL="0">
+              <a:buNone/>
+            </a:pPr>
+            <a:r>
+              <a:rPr lang="en-US" sz="1944" dirty="0">
                 <a:solidFill>
                   <a:srgbClr val="1E293B"/>
                 </a:solidFill>
@@ -2324,14 +2324,14 @@
               </a:rPr>
               <a:t>• Elektroliz testi / yakıt hücresi testi</a:t>
             </a:r>
-            <a:endParaRPr lang="en-US" sz="2750" dirty="0"/>
-          </a:p>
-          <a:p>
-            <a:pPr indent="0" marL="0">
-              <a:buNone/>
-            </a:pPr>
-            <a:r>
-              <a:rPr lang="en-US" sz="2750" dirty="0">
+            <a:endParaRPr lang="en-US" sz="1944" dirty="0"/>
+          </a:p>
+          <a:p>
+            <a:pPr indent="0" marL="0">
+              <a:buNone/>
+            </a:pPr>
+            <a:r>
+              <a:rPr lang="en-US" sz="1944" dirty="0">
                 <a:solidFill>
                   <a:srgbClr val="1E293B"/>
                 </a:solidFill>
@@ -2341,14 +2341,14 @@
               </a:rPr>
               <a:t>• GC/MS, SEM/TEM, EIS veya diğer analizler</a:t>
             </a:r>
-            <a:endParaRPr lang="en-US" sz="2750" dirty="0"/>
-          </a:p>
-          <a:p>
-            <a:pPr indent="0" marL="0">
-              <a:buNone/>
-            </a:pPr>
-            <a:r>
-              <a:rPr lang="en-US" sz="2750" dirty="0">
+            <a:endParaRPr lang="en-US" sz="1944" dirty="0"/>
+          </a:p>
+          <a:p>
+            <a:pPr indent="0" marL="0">
+              <a:buNone/>
+            </a:pPr>
+            <a:r>
+              <a:rPr lang="en-US" sz="1944" dirty="0">
                 <a:solidFill>
                   <a:srgbClr val="1E293B"/>
                 </a:solidFill>
@@ -2358,14 +2358,14 @@
               </a:rPr>
               <a:t>• Modelleme varsayımları ve sınır koşulları</a:t>
             </a:r>
-            <a:endParaRPr lang="en-US" sz="2750" dirty="0"/>
-          </a:p>
-          <a:p>
-            <a:pPr indent="0" marL="0">
-              <a:buNone/>
-            </a:pPr>
-            <a:r>
-              <a:rPr lang="en-US" sz="2750" dirty="0">
+            <a:endParaRPr lang="en-US" sz="1944" dirty="0"/>
+          </a:p>
+          <a:p>
+            <a:pPr indent="0" marL="0">
+              <a:buNone/>
+            </a:pPr>
+            <a:r>
+              <a:rPr lang="en-US" sz="1944" dirty="0">
                 <a:solidFill>
                   <a:srgbClr val="1E293B"/>
                 </a:solidFill>
@@ -2375,7 +2375,7 @@
               </a:rPr>
               <a:t>• Performans metrikleri: verim, güç yoğunluğu, maliyet, emisyon, dayanım vb.</a:t>
             </a:r>
-            <a:endParaRPr lang="en-US" sz="2750" dirty="0"/>
+            <a:endParaRPr lang="en-US" sz="1944" dirty="0"/>
           </a:p>
         </p:txBody>
       </p:sp>
@@ -2387,8 +2387,8 @@
         </p:nvSpPr>
         <p:spPr>
           <a:xfrm>
-            <a:off x="7432853" y="19248120"/>
-            <a:ext cx="6518453" cy="530352"/>
+            <a:off x="5255553" y="13609782"/>
+            <a:ext cx="4609007" cy="374996"/>
           </a:xfrm>
           <a:prstGeom prst="rect">
             <a:avLst/>
@@ -2405,7 +2405,7 @@
           </a:ln>
         </p:spPr>
         <p:txBody>
-          <a:bodyPr wrap="square" lIns="1651" tIns="1651" rIns="1651" bIns="1651" rtlCol="0" anchor="ctr">
+          <a:bodyPr wrap="square" lIns="1167" tIns="1167" rIns="1167" bIns="1167" rtlCol="0" anchor="ctr">
             <a:normAutofit/>
           </a:bodyPr>
           <a:lstStyle/>
@@ -2414,7 +2414,7 @@
               <a:buNone/>
             </a:pPr>
             <a:r>
-              <a:rPr lang="en-US" sz="3000" b="1" dirty="0">
+              <a:rPr lang="en-US" sz="2121" b="1" dirty="0">
                 <a:solidFill>
                   <a:srgbClr val="FFFFFF"/>
                 </a:solidFill>
@@ -2424,7 +2424,7 @@
               </a:rPr>
               <a:t>07  SINIRLILIKLAR &amp; BELİRSİZLİKLER</a:t>
             </a:r>
-            <a:endParaRPr lang="en-US" sz="3000" dirty="0"/>
+            <a:endParaRPr lang="en-US" sz="2121" dirty="0"/>
           </a:p>
         </p:txBody>
       </p:sp>
@@ -2436,8 +2436,8 @@
         </p:nvSpPr>
         <p:spPr>
           <a:xfrm>
-            <a:off x="7432853" y="19833336"/>
-            <a:ext cx="6518453" cy="4489704"/>
+            <a:off x="5255553" y="14023571"/>
+            <a:ext cx="4609007" cy="3174538"/>
           </a:xfrm>
           <a:prstGeom prst="rect">
             <a:avLst/>
@@ -2445,14 +2445,14 @@
           <a:solidFill>
             <a:srgbClr val="FFFFFF"/>
           </a:solidFill>
-          <a:ln w="13970">
+          <a:ln w="9878">
             <a:solidFill>
               <a:srgbClr val="B9D7E5"/>
             </a:solidFill>
           </a:ln>
         </p:spPr>
         <p:txBody>
-          <a:bodyPr wrap="square" lIns="2286" tIns="2286" rIns="2286" bIns="2286" rtlCol="0" anchor="t">
+          <a:bodyPr wrap="square" lIns="1616" tIns="1616" rIns="1616" bIns="1616" rtlCol="0" anchor="t">
             <a:normAutofit/>
           </a:bodyPr>
           <a:lstStyle/>
@@ -2461,7 +2461,7 @@
               <a:buNone/>
             </a:pPr>
             <a:r>
-              <a:rPr lang="en-US" sz="2750" dirty="0">
+              <a:rPr lang="en-US" sz="1944" dirty="0">
                 <a:solidFill>
                   <a:srgbClr val="1E293B"/>
                 </a:solidFill>
@@ -2471,14 +2471,14 @@
               </a:rPr>
               <a:t>Kabul edilebilir belirsizlikleri açıkça belirtin. Örneğin:</a:t>
             </a:r>
-            <a:endParaRPr lang="en-US" sz="2750" dirty="0"/>
-          </a:p>
-          <a:p>
-            <a:pPr indent="0" marL="0">
-              <a:buNone/>
-            </a:pPr>
-            <a:r>
-              <a:rPr lang="en-US" sz="2750" dirty="0">
+            <a:endParaRPr lang="en-US" sz="1944" dirty="0"/>
+          </a:p>
+          <a:p>
+            <a:pPr indent="0" marL="0">
+              <a:buNone/>
+            </a:pPr>
+            <a:r>
+              <a:rPr lang="en-US" sz="1944" dirty="0">
                 <a:solidFill>
                   <a:srgbClr val="1E293B"/>
                 </a:solidFill>
@@ -2488,14 +2488,14 @@
               </a:rPr>
               <a:t>• Ölçüm belirsizliği</a:t>
             </a:r>
-            <a:endParaRPr lang="en-US" sz="2750" dirty="0"/>
-          </a:p>
-          <a:p>
-            <a:pPr indent="0" marL="0">
-              <a:buNone/>
-            </a:pPr>
-            <a:r>
-              <a:rPr lang="en-US" sz="2750" dirty="0">
+            <a:endParaRPr lang="en-US" sz="1944" dirty="0"/>
+          </a:p>
+          <a:p>
+            <a:pPr indent="0" marL="0">
+              <a:buNone/>
+            </a:pPr>
+            <a:r>
+              <a:rPr lang="en-US" sz="1944" dirty="0">
                 <a:solidFill>
                   <a:srgbClr val="1E293B"/>
                 </a:solidFill>
@@ -2505,14 +2505,14 @@
               </a:rPr>
               <a:t>• Numune sayısı / veri kapsamı</a:t>
             </a:r>
-            <a:endParaRPr lang="en-US" sz="2750" dirty="0"/>
-          </a:p>
-          <a:p>
-            <a:pPr indent="0" marL="0">
-              <a:buNone/>
-            </a:pPr>
-            <a:r>
-              <a:rPr lang="en-US" sz="2750" dirty="0">
+            <a:endParaRPr lang="en-US" sz="1944" dirty="0"/>
+          </a:p>
+          <a:p>
+            <a:pPr indent="0" marL="0">
+              <a:buNone/>
+            </a:pPr>
+            <a:r>
+              <a:rPr lang="en-US" sz="1944" dirty="0">
                 <a:solidFill>
                   <a:srgbClr val="1E293B"/>
                 </a:solidFill>
@@ -2522,14 +2522,14 @@
               </a:rPr>
               <a:t>• Model varsayımları</a:t>
             </a:r>
-            <a:endParaRPr lang="en-US" sz="2750" dirty="0"/>
-          </a:p>
-          <a:p>
-            <a:pPr indent="0" marL="0">
-              <a:buNone/>
-            </a:pPr>
-            <a:r>
-              <a:rPr lang="en-US" sz="2750" dirty="0">
+            <a:endParaRPr lang="en-US" sz="1944" dirty="0"/>
+          </a:p>
+          <a:p>
+            <a:pPr indent="0" marL="0">
+              <a:buNone/>
+            </a:pPr>
+            <a:r>
+              <a:rPr lang="en-US" sz="1944" dirty="0">
                 <a:solidFill>
                   <a:srgbClr val="1E293B"/>
                 </a:solidFill>
@@ -2539,20 +2539,20 @@
               </a:rPr>
               <a:t>• Ölçek büyütme riskleri</a:t>
             </a:r>
-            <a:endParaRPr lang="en-US" sz="2750" dirty="0"/>
-          </a:p>
-          <a:p>
-            <a:pPr indent="0" marL="0">
-              <a:buNone/>
-            </a:pPr>
-            <a:endParaRPr lang="en-US" sz="2750" dirty="0"/>
-          </a:p>
-          <a:p>
-            <a:pPr indent="0" marL="0">
-              <a:buNone/>
-            </a:pPr>
-            <a:r>
-              <a:rPr lang="en-US" sz="2750" dirty="0">
+            <a:endParaRPr lang="en-US" sz="1944" dirty="0"/>
+          </a:p>
+          <a:p>
+            <a:pPr indent="0" marL="0">
+              <a:buNone/>
+            </a:pPr>
+            <a:endParaRPr lang="en-US" sz="1944" dirty="0"/>
+          </a:p>
+          <a:p>
+            <a:pPr indent="0" marL="0">
+              <a:buNone/>
+            </a:pPr>
+            <a:r>
+              <a:rPr lang="en-US" sz="1944" dirty="0">
                 <a:solidFill>
                   <a:srgbClr val="1E293B"/>
                 </a:solidFill>
@@ -2562,7 +2562,7 @@
               </a:rPr>
               <a:t>Bu bölüm çalışmayı zayıflatmaz; teknik güvenilirliği artırır.</a:t>
             </a:r>
-            <a:endParaRPr lang="en-US" sz="2750" dirty="0"/>
+            <a:endParaRPr lang="en-US" sz="1944" dirty="0"/>
           </a:p>
         </p:txBody>
       </p:sp>
@@ -2574,8 +2574,8 @@
         </p:nvSpPr>
         <p:spPr>
           <a:xfrm>
-            <a:off x="14271346" y="5715000"/>
-            <a:ext cx="6518453" cy="530352"/>
+            <a:off x="10090851" y="4040909"/>
+            <a:ext cx="4609007" cy="374996"/>
           </a:xfrm>
           <a:prstGeom prst="rect">
             <a:avLst/>
@@ -2592,7 +2592,7 @@
           </a:ln>
         </p:spPr>
         <p:txBody>
-          <a:bodyPr wrap="square" lIns="1651" tIns="1651" rIns="1651" bIns="1651" rtlCol="0" anchor="ctr">
+          <a:bodyPr wrap="square" lIns="1167" tIns="1167" rIns="1167" bIns="1167" rtlCol="0" anchor="ctr">
             <a:normAutofit/>
           </a:bodyPr>
           <a:lstStyle/>
@@ -2601,7 +2601,7 @@
               <a:buNone/>
             </a:pPr>
             <a:r>
-              <a:rPr lang="en-US" sz="3000" b="1" dirty="0">
+              <a:rPr lang="en-US" sz="2121" b="1" dirty="0">
                 <a:solidFill>
                   <a:srgbClr val="FFFFFF"/>
                 </a:solidFill>
@@ -2611,7 +2611,7 @@
               </a:rPr>
               <a:t>08  BULGULAR &amp; TARTIŞMA</a:t>
             </a:r>
-            <a:endParaRPr lang="en-US" sz="3000" dirty="0"/>
+            <a:endParaRPr lang="en-US" sz="2121" dirty="0"/>
           </a:p>
         </p:txBody>
       </p:sp>
@@ -2623,8 +2623,8 @@
         </p:nvSpPr>
         <p:spPr>
           <a:xfrm>
-            <a:off x="14271346" y="6300216"/>
-            <a:ext cx="6518453" cy="1051560"/>
+            <a:off x="10090851" y="4454698"/>
+            <a:ext cx="4609007" cy="743527"/>
           </a:xfrm>
           <a:prstGeom prst="rect">
             <a:avLst/>
@@ -2632,14 +2632,14 @@
           <a:solidFill>
             <a:srgbClr val="FFFFFF"/>
           </a:solidFill>
-          <a:ln w="13970">
+          <a:ln w="9878">
             <a:solidFill>
               <a:srgbClr val="B9D7E5"/>
             </a:solidFill>
           </a:ln>
         </p:spPr>
         <p:txBody>
-          <a:bodyPr wrap="square" lIns="2286" tIns="2286" rIns="2286" bIns="2286" rtlCol="0" anchor="t">
+          <a:bodyPr wrap="square" lIns="1616" tIns="1616" rIns="1616" bIns="1616" rtlCol="0" anchor="t">
             <a:normAutofit/>
           </a:bodyPr>
           <a:lstStyle/>
@@ -2648,7 +2648,7 @@
               <a:buNone/>
             </a:pPr>
             <a:r>
-              <a:rPr lang="en-US" sz="2650" dirty="0">
+              <a:rPr lang="en-US" sz="1874" dirty="0">
                 <a:solidFill>
                   <a:srgbClr val="1E293B"/>
                 </a:solidFill>
@@ -2658,7 +2658,7 @@
               </a:rPr>
               <a:t>Ana sonuçları büyük grafik / tablo ile gösterin. Metni azaltın; veriyi büyütün. Literatürle karşılaştırmayı ve hidrojen teknolojilerine etkisini net yazın.</a:t>
             </a:r>
-            <a:endParaRPr lang="en-US" sz="2650" dirty="0"/>
+            <a:endParaRPr lang="en-US" sz="1874" dirty="0"/>
           </a:p>
         </p:txBody>
       </p:sp>
@@ -2678,8 +2678,8 @@
         </p:blipFill>
         <p:spPr>
           <a:xfrm>
-            <a:off x="14545666" y="7771516"/>
-            <a:ext cx="5969813" cy="6000232"/>
+            <a:off x="10284814" y="5495011"/>
+            <a:ext cx="4221080" cy="4242588"/>
           </a:xfrm>
           <a:prstGeom prst="rect">
             <a:avLst/>
@@ -2694,8 +2694,8 @@
         </p:nvSpPr>
         <p:spPr>
           <a:xfrm>
-            <a:off x="14271346" y="14090904"/>
-            <a:ext cx="6518453" cy="320040"/>
+            <a:off x="10090851" y="9963265"/>
+            <a:ext cx="4609007" cy="226291"/>
           </a:xfrm>
           <a:prstGeom prst="rect">
             <a:avLst/>
@@ -2711,7 +2711,7 @@
               <a:buNone/>
             </a:pPr>
             <a:r>
-              <a:rPr lang="en-US" sz="1600" i="1" dirty="0">
+              <a:rPr lang="en-US" sz="1131" i="1" dirty="0">
                 <a:solidFill>
                   <a:srgbClr val="475569"/>
                 </a:solidFill>
@@ -2721,7 +2721,7 @@
               </a:rPr>
               <a:t>Grafik / tablo alanı: en güçlü 2-3 bulgu burada yer almalı</a:t>
             </a:r>
-            <a:endParaRPr lang="en-US" sz="1600" dirty="0"/>
+            <a:endParaRPr lang="en-US" sz="1131" dirty="0"/>
           </a:p>
         </p:txBody>
       </p:sp>
@@ -2733,8 +2733,8 @@
         </p:nvSpPr>
         <p:spPr>
           <a:xfrm>
-            <a:off x="14271346" y="14676120"/>
-            <a:ext cx="6518453" cy="530352"/>
+            <a:off x="10090851" y="10377055"/>
+            <a:ext cx="4609007" cy="374996"/>
           </a:xfrm>
           <a:prstGeom prst="rect">
             <a:avLst/>
@@ -2751,7 +2751,7 @@
           </a:ln>
         </p:spPr>
         <p:txBody>
-          <a:bodyPr wrap="square" lIns="1651" tIns="1651" rIns="1651" bIns="1651" rtlCol="0" anchor="ctr">
+          <a:bodyPr wrap="square" lIns="1167" tIns="1167" rIns="1167" bIns="1167" rtlCol="0" anchor="ctr">
             <a:normAutofit/>
           </a:bodyPr>
           <a:lstStyle/>
@@ -2760,7 +2760,7 @@
               <a:buNone/>
             </a:pPr>
             <a:r>
-              <a:rPr lang="en-US" sz="3000" b="1" dirty="0">
+              <a:rPr lang="en-US" sz="2121" b="1" dirty="0">
                 <a:solidFill>
                   <a:srgbClr val="FFFFFF"/>
                 </a:solidFill>
@@ -2770,7 +2770,7 @@
               </a:rPr>
               <a:t>09  SONUÇLAR</a:t>
             </a:r>
-            <a:endParaRPr lang="en-US" sz="3000" dirty="0"/>
+            <a:endParaRPr lang="en-US" sz="2121" dirty="0"/>
           </a:p>
         </p:txBody>
       </p:sp>
@@ -2782,8 +2782,8 @@
         </p:nvSpPr>
         <p:spPr>
           <a:xfrm>
-            <a:off x="14271346" y="15261336"/>
-            <a:ext cx="6518453" cy="4078224"/>
+            <a:off x="10090851" y="10790844"/>
+            <a:ext cx="4609007" cy="2883593"/>
           </a:xfrm>
           <a:prstGeom prst="rect">
             <a:avLst/>
@@ -2791,14 +2791,14 @@
           <a:solidFill>
             <a:srgbClr val="FFFFFF"/>
           </a:solidFill>
-          <a:ln w="13970">
+          <a:ln w="9878">
             <a:solidFill>
               <a:srgbClr val="B9D7E5"/>
             </a:solidFill>
           </a:ln>
         </p:spPr>
         <p:txBody>
-          <a:bodyPr wrap="square" lIns="2286" tIns="2286" rIns="2286" bIns="2286" rtlCol="0" anchor="t">
+          <a:bodyPr wrap="square" lIns="1616" tIns="1616" rIns="1616" bIns="1616" rtlCol="0" anchor="t">
             <a:normAutofit/>
           </a:bodyPr>
           <a:lstStyle/>
@@ -2807,7 +2807,7 @@
               <a:buNone/>
             </a:pPr>
             <a:r>
-              <a:rPr lang="en-US" sz="2800" dirty="0">
+              <a:rPr lang="en-US" sz="1980" dirty="0">
                 <a:solidFill>
                   <a:srgbClr val="1E293B"/>
                 </a:solidFill>
@@ -2817,14 +2817,14 @@
               </a:rPr>
               <a:t>• Bulguların 3 ana sonucunu yazın.</a:t>
             </a:r>
-            <a:endParaRPr lang="en-US" sz="2800" dirty="0"/>
-          </a:p>
-          <a:p>
-            <a:pPr indent="0" marL="0">
-              <a:buNone/>
-            </a:pPr>
-            <a:r>
-              <a:rPr lang="en-US" sz="2800" dirty="0">
+            <a:endParaRPr lang="en-US" sz="1980" dirty="0"/>
+          </a:p>
+          <a:p>
+            <a:pPr indent="0" marL="0">
+              <a:buNone/>
+            </a:pPr>
+            <a:r>
+              <a:rPr lang="en-US" sz="1980" dirty="0">
                 <a:solidFill>
                   <a:srgbClr val="1E293B"/>
                 </a:solidFill>
@@ -2834,14 +2834,14 @@
               </a:rPr>
               <a:t>• Literatüre göre farkı / katkıyı belirtin.</a:t>
             </a:r>
-            <a:endParaRPr lang="en-US" sz="2800" dirty="0"/>
-          </a:p>
-          <a:p>
-            <a:pPr indent="0" marL="0">
-              <a:buNone/>
-            </a:pPr>
-            <a:r>
-              <a:rPr lang="en-US" sz="2800" dirty="0">
+            <a:endParaRPr lang="en-US" sz="1980" dirty="0"/>
+          </a:p>
+          <a:p>
+            <a:pPr indent="0" marL="0">
+              <a:buNone/>
+            </a:pPr>
+            <a:r>
+              <a:rPr lang="en-US" sz="1980" dirty="0">
                 <a:solidFill>
                   <a:srgbClr val="1E293B"/>
                 </a:solidFill>
@@ -2851,14 +2851,14 @@
               </a:rPr>
               <a:t>• Uygulama potansiyelini ve ölçeklenebilirlik etkisini vurgulayın.</a:t>
             </a:r>
-            <a:endParaRPr lang="en-US" sz="2800" dirty="0"/>
-          </a:p>
-          <a:p>
-            <a:pPr indent="0" marL="0">
-              <a:buNone/>
-            </a:pPr>
-            <a:r>
-              <a:rPr lang="en-US" sz="2800" dirty="0">
+            <a:endParaRPr lang="en-US" sz="1980" dirty="0"/>
+          </a:p>
+          <a:p>
+            <a:pPr indent="0" marL="0">
+              <a:buNone/>
+            </a:pPr>
+            <a:r>
+              <a:rPr lang="en-US" sz="1980" dirty="0">
                 <a:solidFill>
                   <a:srgbClr val="1E293B"/>
                 </a:solidFill>
@@ -2868,7 +2868,7 @@
               </a:rPr>
               <a:t>• Sonraki deney veya analiz adımını ekleyin.</a:t>
             </a:r>
-            <a:endParaRPr lang="en-US" sz="2800" dirty="0"/>
+            <a:endParaRPr lang="en-US" sz="1980" dirty="0"/>
           </a:p>
         </p:txBody>
       </p:sp>
@@ -2880,8 +2880,8 @@
         </p:nvSpPr>
         <p:spPr>
           <a:xfrm>
-            <a:off x="14271346" y="19613880"/>
-            <a:ext cx="6518453" cy="530352"/>
+            <a:off x="10090851" y="13868400"/>
+            <a:ext cx="4609007" cy="374996"/>
           </a:xfrm>
           <a:prstGeom prst="rect">
             <a:avLst/>
@@ -2898,7 +2898,7 @@
           </a:ln>
         </p:spPr>
         <p:txBody>
-          <a:bodyPr wrap="square" lIns="1651" tIns="1651" rIns="1651" bIns="1651" rtlCol="0" anchor="ctr">
+          <a:bodyPr wrap="square" lIns="1167" tIns="1167" rIns="1167" bIns="1167" rtlCol="0" anchor="ctr">
             <a:normAutofit/>
           </a:bodyPr>
           <a:lstStyle/>
@@ -2907,7 +2907,7 @@
               <a:buNone/>
             </a:pPr>
             <a:r>
-              <a:rPr lang="en-US" sz="3000" b="1" dirty="0">
+              <a:rPr lang="en-US" sz="2121" b="1" dirty="0">
                 <a:solidFill>
                   <a:srgbClr val="FFFFFF"/>
                 </a:solidFill>
@@ -2917,7 +2917,7 @@
               </a:rPr>
               <a:t>10  UYGULAMA ETKİSİ</a:t>
             </a:r>
-            <a:endParaRPr lang="en-US" sz="3000" dirty="0"/>
+            <a:endParaRPr lang="en-US" sz="2121" dirty="0"/>
           </a:p>
         </p:txBody>
       </p:sp>
@@ -2929,8 +2929,8 @@
         </p:nvSpPr>
         <p:spPr>
           <a:xfrm>
-            <a:off x="14271346" y="20199096"/>
-            <a:ext cx="6518453" cy="4123944"/>
+            <a:off x="10090851" y="14282189"/>
+            <a:ext cx="4609007" cy="2915920"/>
           </a:xfrm>
           <a:prstGeom prst="rect">
             <a:avLst/>
@@ -2938,14 +2938,14 @@
           <a:solidFill>
             <a:srgbClr val="FFFFFF"/>
           </a:solidFill>
-          <a:ln w="13970">
+          <a:ln w="9878">
             <a:solidFill>
               <a:srgbClr val="B9D7E5"/>
             </a:solidFill>
           </a:ln>
         </p:spPr>
         <p:txBody>
-          <a:bodyPr wrap="square" lIns="2286" tIns="2286" rIns="2286" bIns="2286" rtlCol="0" anchor="t">
+          <a:bodyPr wrap="square" lIns="1616" tIns="1616" rIns="1616" bIns="1616" rtlCol="0" anchor="t">
             <a:normAutofit/>
           </a:bodyPr>
           <a:lstStyle/>
@@ -2954,7 +2954,7 @@
               <a:buNone/>
             </a:pPr>
             <a:r>
-              <a:rPr lang="en-US" sz="2750" dirty="0">
+              <a:rPr lang="en-US" sz="1944" dirty="0">
                 <a:solidFill>
                   <a:srgbClr val="1E293B"/>
                 </a:solidFill>
@@ -2964,20 +2964,20 @@
               </a:rPr>
               <a:t>Bu çalışmanın hidrojen ekosistemine etkisini tek paragrafta özetleyin:</a:t>
             </a:r>
-            <a:endParaRPr lang="en-US" sz="2750" dirty="0"/>
-          </a:p>
-          <a:p>
-            <a:pPr indent="0" marL="0">
-              <a:buNone/>
-            </a:pPr>
-            <a:endParaRPr lang="en-US" sz="2750" dirty="0"/>
-          </a:p>
-          <a:p>
-            <a:pPr indent="0" marL="0">
-              <a:buNone/>
-            </a:pPr>
-            <a:r>
-              <a:rPr lang="en-US" sz="2750" dirty="0">
+            <a:endParaRPr lang="en-US" sz="1944" dirty="0"/>
+          </a:p>
+          <a:p>
+            <a:pPr indent="0" marL="0">
+              <a:buNone/>
+            </a:pPr>
+            <a:endParaRPr lang="en-US" sz="1944" dirty="0"/>
+          </a:p>
+          <a:p>
+            <a:pPr indent="0" marL="0">
+              <a:buNone/>
+            </a:pPr>
+            <a:r>
+              <a:rPr lang="en-US" sz="1944" dirty="0">
                 <a:solidFill>
                   <a:srgbClr val="1E293B"/>
                 </a:solidFill>
@@ -2987,7 +2987,7 @@
               </a:rPr>
               <a:t>Endüstri, enerji sistemleri, karbon azaltımı, güvenlik, standartlar, maliyet veya verimlilik açısından hangi sorunu çözmeye yaklaşıyor?</a:t>
             </a:r>
-            <a:endParaRPr lang="en-US" sz="2750" dirty="0"/>
+            <a:endParaRPr lang="en-US" sz="1944" dirty="0"/>
           </a:p>
         </p:txBody>
       </p:sp>
@@ -2999,8 +2999,8 @@
         </p:nvSpPr>
         <p:spPr>
           <a:xfrm>
-            <a:off x="594360" y="25008840"/>
-            <a:ext cx="20208240" cy="960120"/>
+            <a:off x="420255" y="17683018"/>
+            <a:ext cx="14288655" cy="678873"/>
           </a:xfrm>
           <a:prstGeom prst="rect">
             <a:avLst/>
@@ -3017,7 +3017,7 @@
           </a:ln>
         </p:spPr>
         <p:txBody>
-          <a:bodyPr wrap="square" lIns="2286" tIns="2286" rIns="2286" bIns="2286" rtlCol="0" anchor="ctr">
+          <a:bodyPr wrap="square" lIns="1616" tIns="1616" rIns="1616" bIns="1616" rtlCol="0" anchor="ctr">
             <a:normAutofit/>
           </a:bodyPr>
           <a:lstStyle/>
@@ -3026,7 +3026,7 @@
               <a:buNone/>
             </a:pPr>
             <a:r>
-              <a:rPr lang="en-US" sz="2800" b="1" dirty="0">
+              <a:rPr lang="en-US" sz="1980" b="1" dirty="0">
                 <a:solidFill>
                   <a:srgbClr val="FFFFFF"/>
                 </a:solidFill>
@@ -3040,7 +3040,7 @@
               <a:buNone/>
             </a:pPr>
             <a:r>
-              <a:rPr lang="en-US" sz="2800" dirty="0">
+              <a:rPr lang="en-US" sz="1980" dirty="0">
                 <a:solidFill>
                   <a:srgbClr val="FFFFFF"/>
                 </a:solidFill>
@@ -3050,7 +3050,7 @@
               </a:rPr>
               <a:t>Posterinizin ana mesajını burada 1 cümlede verin: “Bu çalışma, … sayesinde … alanında ölçülebilir bir katkı sunmaktadır.”</a:t>
             </a:r>
-            <a:endParaRPr lang="en-US" sz="2800" dirty="0"/>
+            <a:endParaRPr lang="en-US" sz="1980" dirty="0"/>
           </a:p>
         </p:txBody>
       </p:sp>
@@ -3062,8 +3062,8 @@
         </p:nvSpPr>
         <p:spPr>
           <a:xfrm>
-            <a:off x="594360" y="26133552"/>
-            <a:ext cx="20208240" cy="749808"/>
+            <a:off x="420255" y="18478269"/>
+            <a:ext cx="14288655" cy="530167"/>
           </a:xfrm>
           <a:prstGeom prst="rect">
             <a:avLst/>
@@ -3071,14 +3071,14 @@
           <a:solidFill>
             <a:srgbClr val="EAF7FB"/>
           </a:solidFill>
-          <a:ln w="12700">
+          <a:ln w="8980">
             <a:solidFill>
               <a:srgbClr val="B9D7E5"/>
             </a:solidFill>
           </a:ln>
         </p:spPr>
         <p:txBody>
-          <a:bodyPr wrap="square" lIns="1778" tIns="1778" rIns="1778" bIns="1778" rtlCol="0" anchor="ctr">
+          <a:bodyPr wrap="square" lIns="1257" tIns="1257" rIns="1257" bIns="1257" rtlCol="0" anchor="ctr">
             <a:normAutofit/>
           </a:bodyPr>
           <a:lstStyle/>
@@ -3087,7 +3087,7 @@
               <a:buNone/>
             </a:pPr>
             <a:r>
-              <a:rPr lang="en-US" sz="2400" dirty="0">
+              <a:rPr lang="en-US" sz="1697" dirty="0">
                 <a:solidFill>
                   <a:srgbClr val="102033"/>
                 </a:solidFill>
@@ -3097,7 +3097,7 @@
               </a:rPr>
               <a:t>Hızlı kontrol: Başlık kısa mı?  ·  Amaç net mi?  ·  Yöntem 10 saniyede anlaşılıyor mu?  ·  En az bir grafik/tablo var mı?  ·  Sonuç özgün katkıya bağlanıyor mu?</a:t>
             </a:r>
-            <a:endParaRPr lang="en-US" sz="2400" dirty="0"/>
+            <a:endParaRPr lang="en-US" sz="1697" dirty="0"/>
           </a:p>
         </p:txBody>
       </p:sp>
@@ -3109,8 +3109,8 @@
         </p:nvSpPr>
         <p:spPr>
           <a:xfrm>
-            <a:off x="0" y="27980640"/>
-            <a:ext cx="21384158" cy="2295144"/>
+            <a:off x="0" y="19784291"/>
+            <a:ext cx="15120112" cy="1622829"/>
           </a:xfrm>
           <a:prstGeom prst="rect">
             <a:avLst/>
@@ -3118,7 +3118,7 @@
           <a:solidFill>
             <a:srgbClr val="061A2D"/>
           </a:solidFill>
-          <a:ln w="12700">
+          <a:ln w="8980">
             <a:solidFill>
               <a:srgbClr val="061A2D">
                 <a:alpha val="0"/>
@@ -3136,8 +3136,8 @@
         </p:nvSpPr>
         <p:spPr>
           <a:xfrm>
-            <a:off x="0" y="27907488"/>
-            <a:ext cx="21384158" cy="73152"/>
+            <a:off x="0" y="19732567"/>
+            <a:ext cx="15120112" cy="51724"/>
           </a:xfrm>
           <a:prstGeom prst="rect">
             <a:avLst/>
@@ -3145,7 +3145,7 @@
           <a:solidFill>
             <a:srgbClr val="00C8FF"/>
           </a:solidFill>
-          <a:ln w="12700">
+          <a:ln w="8980">
             <a:solidFill>
               <a:srgbClr val="00C8FF">
                 <a:alpha val="0"/>
@@ -3163,8 +3163,8 @@
         </p:nvSpPr>
         <p:spPr>
           <a:xfrm>
-            <a:off x="731520" y="28200096"/>
-            <a:ext cx="2194560" cy="320040"/>
+            <a:off x="517236" y="19939462"/>
+            <a:ext cx="1551709" cy="226291"/>
           </a:xfrm>
           <a:prstGeom prst="rect">
             <a:avLst/>
@@ -3180,7 +3180,7 @@
               <a:buNone/>
             </a:pPr>
             <a:r>
-              <a:rPr lang="en-US" sz="1800" b="1" dirty="0">
+              <a:rPr lang="en-US" sz="1273" b="1" dirty="0">
                 <a:solidFill>
                   <a:srgbClr val="00C8FF"/>
                 </a:solidFill>
@@ -3190,7 +3190,7 @@
               </a:rPr>
               <a:t>KAYNAKÇA</a:t>
             </a:r>
-            <a:endParaRPr lang="en-US" sz="1800" dirty="0"/>
+            <a:endParaRPr lang="en-US" sz="1273" dirty="0"/>
           </a:p>
         </p:txBody>
       </p:sp>
@@ -3202,8 +3202,8 @@
         </p:nvSpPr>
         <p:spPr>
           <a:xfrm>
-            <a:off x="731520" y="28565856"/>
-            <a:ext cx="9144000" cy="868680"/>
+            <a:off x="517236" y="20198080"/>
+            <a:ext cx="6465455" cy="614218"/>
           </a:xfrm>
           <a:prstGeom prst="rect">
             <a:avLst/>
@@ -3212,7 +3212,7 @@
           <a:ln/>
         </p:spPr>
         <p:txBody>
-          <a:bodyPr wrap="square" lIns="254" tIns="254" rIns="254" bIns="254" rtlCol="0" anchor="ctr">
+          <a:bodyPr wrap="square" lIns="180" tIns="180" rIns="180" bIns="180" rtlCol="0" anchor="ctr">
             <a:normAutofit/>
           </a:bodyPr>
           <a:lstStyle/>
@@ -3221,7 +3221,7 @@
               <a:buNone/>
             </a:pPr>
             <a:r>
-              <a:rPr lang="en-US" sz="2000" dirty="0">
+              <a:rPr lang="en-US" sz="1414" dirty="0">
                 <a:solidFill>
                   <a:srgbClr val="D7E7EE"/>
                 </a:solidFill>
@@ -3231,7 +3231,7 @@
               </a:rPr>
               <a:t>[1] Yazar, “Makale başlığı,” Dergi, yıl.  [2] Yazar, Rapor başlığı, kurum, yıl.  [3] Standart / veri kaynağı.</a:t>
             </a:r>
-            <a:endParaRPr lang="en-US" sz="2000" dirty="0"/>
+            <a:endParaRPr lang="en-US" sz="1414" dirty="0"/>
           </a:p>
         </p:txBody>
       </p:sp>
@@ -3243,8 +3243,8 @@
         </p:nvSpPr>
         <p:spPr>
           <a:xfrm>
-            <a:off x="10195560" y="28200096"/>
-            <a:ext cx="1828800" cy="320040"/>
+            <a:off x="7208982" y="19939462"/>
+            <a:ext cx="1293091" cy="226291"/>
           </a:xfrm>
           <a:prstGeom prst="rect">
             <a:avLst/>
@@ -3260,7 +3260,7 @@
               <a:buNone/>
             </a:pPr>
             <a:r>
-              <a:rPr lang="en-US" sz="1800" b="1" dirty="0">
+              <a:rPr lang="en-US" sz="1273" b="1" dirty="0">
                 <a:solidFill>
                   <a:srgbClr val="00C8FF"/>
                 </a:solidFill>
@@ -3270,7 +3270,7 @@
               </a:rPr>
               <a:t>TEŞEKKÜR</a:t>
             </a:r>
-            <a:endParaRPr lang="en-US" sz="1800" dirty="0"/>
+            <a:endParaRPr lang="en-US" sz="1273" dirty="0"/>
           </a:p>
         </p:txBody>
       </p:sp>
@@ -3282,8 +3282,8 @@
         </p:nvSpPr>
         <p:spPr>
           <a:xfrm>
-            <a:off x="10195560" y="28565856"/>
-            <a:ext cx="4572000" cy="868680"/>
+            <a:off x="7208982" y="20198080"/>
+            <a:ext cx="3232727" cy="614218"/>
           </a:xfrm>
           <a:prstGeom prst="rect">
             <a:avLst/>
@@ -3292,7 +3292,7 @@
           <a:ln/>
         </p:spPr>
         <p:txBody>
-          <a:bodyPr wrap="square" lIns="254" tIns="254" rIns="254" bIns="254" rtlCol="0" anchor="ctr">
+          <a:bodyPr wrap="square" lIns="180" tIns="180" rIns="180" bIns="180" rtlCol="0" anchor="ctr">
             <a:normAutofit/>
           </a:bodyPr>
           <a:lstStyle/>
@@ -3301,7 +3301,7 @@
               <a:buNone/>
             </a:pPr>
             <a:r>
-              <a:rPr lang="en-US" sz="2000" dirty="0">
+              <a:rPr lang="en-US" sz="1414" dirty="0">
                 <a:solidFill>
                   <a:srgbClr val="D7E7EE"/>
                 </a:solidFill>
@@ -3311,7 +3311,7 @@
               </a:rPr>
               <a:t>Fon, proje, laboratuvar, kurum ve işbirliği desteklerini kısa ve profesyonel biçimde yazın.</a:t>
             </a:r>
-            <a:endParaRPr lang="en-US" sz="2000" dirty="0"/>
+            <a:endParaRPr lang="en-US" sz="1414" dirty="0"/>
           </a:p>
         </p:txBody>
       </p:sp>
@@ -3323,8 +3323,8 @@
         </p:nvSpPr>
         <p:spPr>
           <a:xfrm>
-            <a:off x="15087600" y="28200096"/>
-            <a:ext cx="1828800" cy="320040"/>
+            <a:off x="10668000" y="19939462"/>
+            <a:ext cx="1293091" cy="226291"/>
           </a:xfrm>
           <a:prstGeom prst="rect">
             <a:avLst/>
@@ -3340,7 +3340,7 @@
               <a:buNone/>
             </a:pPr>
             <a:r>
-              <a:rPr lang="en-US" sz="1800" b="1" dirty="0">
+              <a:rPr lang="en-US" sz="1273" b="1" dirty="0">
                 <a:solidFill>
                   <a:srgbClr val="00C8FF"/>
                 </a:solidFill>
@@ -3350,7 +3350,7 @@
               </a:rPr>
               <a:t>İLETİŞİM</a:t>
             </a:r>
-            <a:endParaRPr lang="en-US" sz="1800" dirty="0"/>
+            <a:endParaRPr lang="en-US" sz="1273" dirty="0"/>
           </a:p>
         </p:txBody>
       </p:sp>
@@ -3362,8 +3362,8 @@
         </p:nvSpPr>
         <p:spPr>
           <a:xfrm>
-            <a:off x="15087600" y="28565856"/>
-            <a:ext cx="3108960" cy="868680"/>
+            <a:off x="10668000" y="20198080"/>
+            <a:ext cx="2198255" cy="614218"/>
           </a:xfrm>
           <a:prstGeom prst="rect">
             <a:avLst/>
@@ -3372,7 +3372,7 @@
           <a:ln/>
         </p:spPr>
         <p:txBody>
-          <a:bodyPr wrap="square" lIns="254" tIns="254" rIns="254" bIns="254" rtlCol="0" anchor="ctr">
+          <a:bodyPr wrap="square" lIns="180" tIns="180" rIns="180" bIns="180" rtlCol="0" anchor="ctr">
             <a:normAutofit/>
           </a:bodyPr>
           <a:lstStyle/>
@@ -3381,7 +3381,7 @@
               <a:buNone/>
             </a:pPr>
             <a:r>
-              <a:rPr lang="en-US" sz="2000" dirty="0">
+              <a:rPr lang="en-US" sz="1414" dirty="0">
                 <a:solidFill>
                   <a:srgbClr val="D7E7EE"/>
                 </a:solidFill>
@@ -3391,14 +3391,14 @@
               </a:rPr>
               <a:t>e-posta · kurum · LinkedIn</a:t>
             </a:r>
-            <a:endParaRPr lang="en-US" sz="2000" dirty="0"/>
-          </a:p>
-          <a:p>
-            <a:pPr indent="0" marL="0">
-              <a:buNone/>
-            </a:pPr>
-            <a:r>
-              <a:rPr lang="en-US" sz="2000" dirty="0">
+            <a:endParaRPr lang="en-US" sz="1414" dirty="0"/>
+          </a:p>
+          <a:p>
+            <a:pPr indent="0" marL="0">
+              <a:buNone/>
+            </a:pPr>
+            <a:r>
+              <a:rPr lang="en-US" sz="1414" dirty="0">
                 <a:solidFill>
                   <a:srgbClr val="D7E7EE"/>
                 </a:solidFill>
@@ -3408,7 +3408,7 @@
               </a:rPr>
               <a:t>QR: tam metin / proje sayfası</a:t>
             </a:r>
-            <a:endParaRPr lang="en-US" sz="2000" dirty="0"/>
+            <a:endParaRPr lang="en-US" sz="1414" dirty="0"/>
           </a:p>
         </p:txBody>
       </p:sp>
@@ -3420,8 +3420,8 @@
         </p:nvSpPr>
         <p:spPr>
           <a:xfrm>
-            <a:off x="19065240" y="28181808"/>
-            <a:ext cx="1417320" cy="1417320"/>
+            <a:off x="13480473" y="19926531"/>
+            <a:ext cx="1002145" cy="1002145"/>
           </a:xfrm>
           <a:prstGeom prst="rect">
             <a:avLst/>
@@ -3429,7 +3429,7 @@
           <a:solidFill>
             <a:srgbClr val="0A2238"/>
           </a:solidFill>
-          <a:ln w="15240">
+          <a:ln w="10776">
             <a:solidFill>
               <a:srgbClr val="00C8FF"/>
             </a:solidFill>
@@ -3443,7 +3443,7 @@
               <a:buNone/>
             </a:pPr>
             <a:r>
-              <a:rPr lang="en-US" sz="3200" b="1" dirty="0">
+              <a:rPr lang="en-US" sz="2263" b="1" dirty="0">
                 <a:solidFill>
                   <a:srgbClr val="00C8FF"/>
                 </a:solidFill>
@@ -3453,7 +3453,7 @@
               </a:rPr>
               <a:t>QR</a:t>
             </a:r>
-            <a:endParaRPr lang="en-US" sz="3200" dirty="0"/>
+            <a:endParaRPr lang="en-US" sz="2263" dirty="0"/>
           </a:p>
         </p:txBody>
       </p:sp>
@@ -3465,8 +3465,8 @@
         </p:nvSpPr>
         <p:spPr>
           <a:xfrm>
-            <a:off x="18333720" y="29672280"/>
-            <a:ext cx="2377440" cy="228600"/>
+            <a:off x="12963236" y="20980400"/>
+            <a:ext cx="1681018" cy="161636"/>
           </a:xfrm>
           <a:prstGeom prst="rect">
             <a:avLst/>
@@ -3482,7 +3482,7 @@
               <a:buNone/>
             </a:pPr>
             <a:r>
-              <a:rPr lang="en-US" sz="1400" dirty="0">
+              <a:rPr lang="en-US" sz="990" dirty="0">
                 <a:solidFill>
                   <a:srgbClr val="A7DFF0"/>
                 </a:solidFill>
@@ -3492,7 +3492,7 @@
               </a:rPr>
               <a:t>#TürkiyeHidrojenZirvesi</a:t>
             </a:r>
-            <a:endParaRPr lang="en-US" sz="1400" dirty="0"/>
+            <a:endParaRPr lang="en-US" sz="990" dirty="0"/>
           </a:p>
         </p:txBody>
       </p:sp>

</xml_diff>